<commit_message>
Update all 15 showcase samples with rich imagery, charts, and PowerPoint Morph transitions
</commit_message>
<xml_diff>
--- a/freelance/samples/pptx/Life_and_Works_of_Jose_Rizal.pptx
+++ b/freelance/samples/pptx/Life_and_Works_of_Jose_Rizal.pptx
@@ -512,7 +512,7 @@
           <a:lstStyle/>
           <a:p>
             <a:r>
-              <a:t>Welcome panel. Today we analyze Dr. Jose Rizal not merely as a historical monument, but as an intellectual revolutionary whose literary works ignited Filipino nationhood.</a:t>
+              <a:t>Magandang araw. Today we explore the extraordinary life, literary masterpieces, and enduring patriotic legacy of Dr. Jose Protacio Rizal Mercado y Alonso Realonda.</a:t>
             </a:r>
           </a:p>
         </p:txBody>
@@ -582,7 +582,7 @@
           <a:lstStyle/>
           <a:p>
             <a:r>
-              <a:t>Rizal calls modern students at STI West Negros University to reject apathy, excel in our chosen technical disciplines, and serve our communities with unyielding integrity.</a:t>
+              <a:t>This chronology traces Rizal's 35 years of purposeful life. His martyrdom sealed the fate of the Spanish empire in Asia and catalyzed the birth of the first democratic republic in the region.</a:t>
             </a:r>
           </a:p>
         </p:txBody>
@@ -652,7 +652,7 @@
           <a:lstStyle/>
           <a:p>
             <a:r>
-              <a:t>Thank you. Here are our verified academic sources from Guerrero, Schumacher, and the National Historical Commission.</a:t>
+              <a:t>Rizal left us with the immortal charge: 'Where is the youth who will consecrate their golden hours to the welfare of their native land?' As STI students, let us honor that call.</a:t>
             </a:r>
           </a:p>
         </p:txBody>
@@ -722,7 +722,7 @@
           <a:lstStyle/>
           <a:p>
             <a:r>
-              <a:t>Our roadmap explores Rizal's early education, his seminal propaganda novels, his civic reformism in Dapitan, and his timeless legacy for Filipino youth.</a:t>
+              <a:t>Rizal's intellect was fostered in Calamba. The unjust execution of Gomburza in 1872, when Rizal was just eleven years old, dedicated his life to avenging the victims of colonial injustice.</a:t>
             </a:r>
           </a:p>
         </p:txBody>
@@ -792,7 +792,7 @@
           <a:lstStyle/>
           <a:p>
             <a:r>
-              <a:t>Rizal proved that ideas, articulate prose, and moral conviction can shatter centuries of colonial oppression more enduringly than violent conquest.</a:t>
+              <a:t>Rizal's academic journey took him to Ateneo Municipal where he graduated with highest honors, followed by medical studies at the University of Santo Tomas.</a:t>
             </a:r>
           </a:p>
         </p:txBody>
@@ -862,7 +862,7 @@
           <a:lstStyle/>
           <a:p>
             <a:r>
-              <a:t>Part One examines how Rizal deployed satirical realism to awaken a fractured archipelago into a unified nation.</a:t>
+              <a:t>In Europe, Rizal proved Filipino equality through intellectual rigor. His annotations of Morga's history destroyed the colonial myth that the Philippines was uncivilized prior to Spanish arrival.</a:t>
             </a:r>
           </a:p>
         </p:txBody>
@@ -932,7 +932,7 @@
           <a:lstStyle/>
           <a:p>
             <a:r>
-              <a:t>These remarkable metrics demonstrate Rizal's extraordinary polymathic dedication to Philippine sovereignty and intellectual freedom.</a:t>
+              <a:t>These three demands formed the bedrock of the peaceful reform movement, demonstrating Rizal's belief in legal enlightenment before armed struggle.</a:t>
             </a:r>
           </a:p>
         </p:txBody>
@@ -1002,7 +1002,7 @@
           <a:lstStyle/>
           <a:p>
             <a:r>
-              <a:t>Rizal's philosophy rested upon universal education, cooperative community industry, and fearless critical thinking.</a:t>
+              <a:t>Noli Me Tangere was a literary bombshell. By diagnosing the social cancer of the colony, Rizal forced Spaniards and Filipinos alike to confront the realities of oppression.</a:t>
             </a:r>
           </a:p>
         </p:txBody>
@@ -1072,7 +1072,7 @@
           <a:lstStyle/>
           <a:p>
             <a:r>
-              <a:t>Here we contrast the hopeful reformism of the Noli against the grim, radical warning embodied in El Filibusterismo.</a:t>
+              <a:t>Four years later, Rizal published El Filibusterismo in Ghent, Belgium, aided by Valentin Ventura. The tone shifts from romantic idealism to dark revolutionary reckoning.</a:t>
             </a:r>
           </a:p>
         </p:txBody>
@@ -1142,7 +1142,7 @@
           <a:lstStyle/>
           <a:p>
             <a:r>
-              <a:t>Part Two investigates Rizal's exile in Dapitan, where he demonstrated how an educated patriot serves community health and agricultural development.</a:t>
+              <a:t>During his four-year exile in Dapitan, Rizal exemplified practical patriotism. He did not languish in despair; he built schools, water systems, and treated impoverished patients for free.</a:t>
             </a:r>
           </a:p>
         </p:txBody>
@@ -1212,7 +1212,7 @@
           <a:lstStyle/>
           <a:p>
             <a:r>
-              <a:t>In Dapitan, Rizal built clean waterworks, treated the sick without charge, and taught practical science to rural youth.</a:t>
+              <a:t>Rizal's life reminds modern IT students that technical skill without moral courage and civic devotion is empty. We are called to be digital builders for the nation.</a:t>
             </a:r>
           </a:p>
         </p:txBody>
@@ -4209,7 +4209,7 @@
 </file>
 
 <file path=ppt/slides/slide1.xml><?xml version="1.0" encoding="utf-8"?>
-<p:sld xmlns:a="http://schemas.openxmlformats.org/drawingml/2006/main" xmlns:p="http://schemas.openxmlformats.org/presentationml/2006/main" xmlns:r="http://schemas.openxmlformats.org/officeDocument/2006/relationships">
+<p:sld xmlns:p14="http://schemas.microsoft.com/office/powerpoint/2010/main" xmlns:a="http://schemas.openxmlformats.org/drawingml/2006/main" xmlns:p="http://schemas.openxmlformats.org/presentationml/2006/main" xmlns:r="http://schemas.openxmlformats.org/officeDocument/2006/relationships">
   <p:cSld>
     <p:spTree>
       <p:nvGrpSpPr>
@@ -4261,68 +4261,40 @@
           </a:p>
         </p:txBody>
       </p:sp>
-      <p:sp>
-        <p:nvSpPr>
-          <p:cNvPr id="3" name="Rounded Rectangle 2"/>
-          <p:cNvSpPr/>
+      <p:pic>
+        <p:nvPicPr>
+          <p:cNvPr id="3" name="!!Hero_Image" descr="rizal_hero.png"/>
+          <p:cNvPicPr>
+            <a:picLocks noChangeAspect="1"/>
+          </p:cNvPicPr>
           <p:nvPr/>
-        </p:nvSpPr>
-        <p:spPr>
-          <a:xfrm>
-            <a:off x="731520" y="1097280"/>
-            <a:ext cx="3474720" cy="411480"/>
-          </a:xfrm>
-          <a:prstGeom prst="roundRect">
+        </p:nvPicPr>
+        <p:blipFill>
+          <a:blip r:embed="rId2"/>
+          <a:stretch>
+            <a:fillRect/>
+          </a:stretch>
+        </p:blipFill>
+        <p:spPr>
+          <a:xfrm>
+            <a:off x="6217920" y="731520"/>
+            <a:ext cx="5303520" cy="5394960"/>
+          </a:xfrm>
+          <a:prstGeom prst="rect">
             <a:avLst/>
           </a:prstGeom>
-          <a:solidFill>
-            <a:srgbClr val="3E7CB1"/>
-          </a:solidFill>
-          <a:ln>
-            <a:noFill/>
-          </a:ln>
-        </p:spPr>
-        <p:style>
-          <a:lnRef idx="1">
-            <a:schemeClr val="accent1"/>
-          </a:lnRef>
-          <a:fillRef idx="3">
-            <a:schemeClr val="accent1"/>
-          </a:fillRef>
-          <a:effectRef idx="2">
-            <a:schemeClr val="accent1"/>
-          </a:effectRef>
-          <a:fontRef idx="minor">
-            <a:schemeClr val="lt1"/>
-          </a:fontRef>
-        </p:style>
-        <p:txBody>
-          <a:bodyPr rtlCol="0" anchor="ctr"/>
-          <a:lstStyle/>
-          <a:p>
-            <a:pPr algn="ctr">
-              <a:defRPr sz="1000" b="1">
-                <a:solidFill>
-                  <a:srgbClr val="FFFFFF"/>
-                </a:solidFill>
-              </a:defRPr>
-            </a:pPr>
-            <a:r>
-              <a:t>ACADEMIC KEYNOTE PRESENTATION</a:t>
-            </a:r>
-          </a:p>
-        </p:txBody>
-      </p:sp>
-      <p:sp>
-        <p:nvSpPr>
-          <p:cNvPr id="4" name="TextBox 3"/>
+        </p:spPr>
+      </p:pic>
+      <p:sp>
+        <p:nvSpPr>
+          <p:cNvPr id="4" name="!!Title_Card"/>
           <p:cNvSpPr txBox="1"/>
           <p:nvPr/>
         </p:nvSpPr>
         <p:spPr>
           <a:xfrm>
-            <a:off x="731520" y="1828800"/>
-            <a:ext cx="10515600" cy="2011680"/>
+            <a:off x="731520" y="1463040"/>
+            <a:ext cx="5303520" cy="4114800"/>
           </a:xfrm>
           <a:prstGeom prst="rect">
             <a:avLst/>
@@ -4330,13 +4302,25 @@
           <a:noFill/>
         </p:spPr>
         <p:txBody>
-          <a:bodyPr wrap="none">
+          <a:bodyPr wrap="square">
             <a:spAutoFit/>
           </a:bodyPr>
           <a:lstStyle/>
           <a:p>
             <a:pPr>
-              <a:defRPr sz="4000" b="1">
+              <a:defRPr sz="1200" b="1">
+                <a:solidFill>
+                  <a:srgbClr val="F2B705"/>
+                </a:solidFill>
+              </a:defRPr>
+            </a:pPr>
+            <a:r>
+              <a:t>PHILIPPINE HISTORY &amp; GOVERNANCE</a:t>
+            </a:r>
+          </a:p>
+          <a:p>
+            <a:pPr>
+              <a:defRPr sz="3600" b="1">
                 <a:solidFill>
                   <a:srgbClr val="FFFFFF"/>
                 </a:solidFill>
@@ -4346,78 +4330,29 @@
               <a:t>The Life and Works of Jose Rizal</a:t>
             </a:r>
           </a:p>
-        </p:txBody>
-      </p:sp>
-      <p:sp>
-        <p:nvSpPr>
-          <p:cNvPr id="5" name="TextBox 4"/>
-          <p:cNvSpPr txBox="1"/>
-          <p:nvPr/>
-        </p:nvSpPr>
-        <p:spPr>
-          <a:xfrm>
-            <a:off x="731520" y="3931920"/>
-            <a:ext cx="10515600" cy="914400"/>
-          </a:xfrm>
-          <a:prstGeom prst="rect">
-            <a:avLst/>
-          </a:prstGeom>
-          <a:noFill/>
-        </p:spPr>
-        <p:txBody>
-          <a:bodyPr wrap="none">
-            <a:spAutoFit/>
-          </a:bodyPr>
-          <a:lstStyle/>
           <a:p>
             <a:pPr>
-              <a:defRPr sz="2000">
-                <a:solidFill>
-                  <a:srgbClr val="F2B705"/>
+              <a:defRPr sz="1500">
+                <a:solidFill>
+                  <a:srgbClr val="B4C8DC"/>
                 </a:solidFill>
               </a:defRPr>
             </a:pPr>
             <a:r>
-              <a:t>Nationalism, Intellectual Resistance, and the Awakening of Filipino Identity</a:t>
-            </a:r>
-          </a:p>
-        </p:txBody>
-      </p:sp>
-      <p:sp>
-        <p:nvSpPr>
-          <p:cNvPr id="6" name="TextBox 5"/>
-          <p:cNvSpPr txBox="1"/>
-          <p:nvPr/>
-        </p:nvSpPr>
-        <p:spPr>
-          <a:xfrm>
-            <a:off x="731520" y="5120640"/>
-            <a:ext cx="10515600" cy="914400"/>
-          </a:xfrm>
-          <a:prstGeom prst="rect">
-            <a:avLst/>
-          </a:prstGeom>
-          <a:noFill/>
-        </p:spPr>
-        <p:txBody>
-          <a:bodyPr wrap="none">
-            <a:spAutoFit/>
-          </a:bodyPr>
-          <a:lstStyle/>
-          <a:p>
+              <a:t>Nationalism, Literary Genius, and the Awakening of the Filipino Consciousness</a:t>
+            </a:r>
+          </a:p>
+          <a:p>
+            <a:br/>
             <a:pPr>
-              <a:defRPr sz="1400">
-                <a:solidFill>
-                  <a:srgbClr val="93C5FD"/>
+              <a:defRPr sz="1100">
+                <a:solidFill>
+                  <a:srgbClr val="8CA0B4"/>
                 </a:solidFill>
               </a:defRPr>
             </a:pPr>
             <a:r>
-              <a:t>Presented by: Jhon Paulo V. Gascon  •  BSIT 2G</a:t>
-            </a:r>
-            <a:br/>
-            <a:r>
-              <a:t>STI West Negros University  •  Academic Year 2026–2027</a:t>
+              <a:t>Presenter: Jhon Paulo Gascon • STI West Negros University</a:t>
             </a:r>
           </a:p>
         </p:txBody>
@@ -4427,14 +4362,14 @@
   <p:clrMapOvr>
     <a:masterClrMapping/>
   </p:clrMapOvr>
-  <p:transition spd="slow">
+  <p:transition spd="med">
     <p:fade/>
   </p:transition>
 </p:sld>
 </file>
 
 <file path=ppt/slides/slide10.xml><?xml version="1.0" encoding="utf-8"?>
-<p:sld xmlns:a="http://schemas.openxmlformats.org/drawingml/2006/main" xmlns:p="http://schemas.openxmlformats.org/presentationml/2006/main" xmlns:r="http://schemas.openxmlformats.org/officeDocument/2006/relationships">
+<p:sld xmlns:p14="http://schemas.microsoft.com/office/powerpoint/2010/main" xmlns:a="http://schemas.openxmlformats.org/drawingml/2006/main" xmlns:p="http://schemas.openxmlformats.org/presentationml/2006/main" xmlns:r="http://schemas.openxmlformats.org/officeDocument/2006/relationships">
   <p:cSld>
     <p:spTree>
       <p:nvGrpSpPr>
@@ -4494,8 +4429,8 @@
         </p:nvSpPr>
         <p:spPr>
           <a:xfrm>
-            <a:off x="731520" y="365760"/>
-            <a:ext cx="10058400" cy="365760"/>
+            <a:off x="731520" y="457200"/>
+            <a:ext cx="10698480" cy="1005840"/>
           </a:xfrm>
           <a:prstGeom prst="rect">
             <a:avLst/>
@@ -4503,7 +4438,7 @@
           <a:noFill/>
         </p:spPr>
         <p:txBody>
-          <a:bodyPr wrap="none">
+          <a:bodyPr wrap="square">
             <a:spAutoFit/>
           </a:bodyPr>
           <a:lstStyle/>
@@ -4516,97 +4451,39 @@
               </a:defRPr>
             </a:pPr>
             <a:r>
-              <a:t>FINAL INSIGHTS</a:t>
-            </a:r>
-          </a:p>
-        </p:txBody>
-      </p:sp>
-      <p:sp>
-        <p:nvSpPr>
-          <p:cNvPr id="4" name="TextBox 3"/>
-          <p:cNvSpPr txBox="1"/>
-          <p:nvPr/>
-        </p:nvSpPr>
-        <p:spPr>
-          <a:xfrm>
-            <a:off x="731520" y="685800"/>
-            <a:ext cx="10515600" cy="731520"/>
-          </a:xfrm>
-          <a:prstGeom prst="rect">
-            <a:avLst/>
-          </a:prstGeom>
-          <a:noFill/>
-        </p:spPr>
-        <p:txBody>
-          <a:bodyPr wrap="none">
-            <a:spAutoFit/>
-          </a:bodyPr>
-          <a:lstStyle/>
+              <a:t>TIMELINE</a:t>
+            </a:r>
+          </a:p>
           <a:p>
             <a:pPr>
-              <a:defRPr sz="2600" b="1">
+              <a:defRPr sz="2400" b="1">
                 <a:solidFill>
                   <a:srgbClr val="FFFFFF"/>
                 </a:solidFill>
               </a:defRPr>
             </a:pPr>
             <a:r>
-              <a:t>Rizal's Challenge to 21st-Century Youth</a:t>
-            </a:r>
-          </a:p>
-        </p:txBody>
-      </p:sp>
-      <p:sp>
-        <p:nvSpPr>
-          <p:cNvPr id="5" name="TextBox 4"/>
-          <p:cNvSpPr txBox="1"/>
-          <p:nvPr/>
-        </p:nvSpPr>
-        <p:spPr>
-          <a:xfrm>
-            <a:off x="731520" y="6400800"/>
-            <a:ext cx="10728655" cy="320040"/>
-          </a:xfrm>
-          <a:prstGeom prst="rect">
-            <a:avLst/>
-          </a:prstGeom>
-          <a:noFill/>
-        </p:spPr>
-        <p:txBody>
-          <a:bodyPr wrap="none">
-            <a:spAutoFit/>
-          </a:bodyPr>
-          <a:lstStyle/>
-          <a:p>
-            <a:pPr>
-              <a:defRPr sz="900">
-                <a:solidFill>
-                  <a:srgbClr val="93C5FD"/>
-                </a:solidFill>
-              </a:defRPr>
-            </a:pPr>
-            <a:r>
-              <a:t>STI West Negros University  •  Jhon Paulo V. Gascon  •  Slide 10 of 11</a:t>
-            </a:r>
-          </a:p>
-        </p:txBody>
-      </p:sp>
-      <p:sp>
-        <p:nvSpPr>
-          <p:cNvPr id="6" name="Rounded Rectangle 5"/>
+              <a:t>Historical Chronology &amp; Milestones</a:t>
+            </a:r>
+          </a:p>
+        </p:txBody>
+      </p:sp>
+      <p:sp>
+        <p:nvSpPr>
+          <p:cNvPr id="4" name="!!Card_1"/>
           <p:cNvSpPr/>
           <p:nvPr/>
         </p:nvSpPr>
         <p:spPr>
           <a:xfrm>
-            <a:off x="731520" y="1828800"/>
-            <a:ext cx="10728655" cy="1188720"/>
+            <a:off x="731520" y="1645920"/>
+            <a:ext cx="3291840" cy="4114800"/>
           </a:xfrm>
           <a:prstGeom prst="roundRect">
             <a:avLst/>
           </a:prstGeom>
           <a:solidFill>
-            <a:srgbClr val="183B64"/>
+            <a:srgbClr val="193A62"/>
           </a:solidFill>
           <a:ln w="19050">
             <a:solidFill>
@@ -4629,79 +4506,50 @@
           </a:fontRef>
         </p:style>
         <p:txBody>
-          <a:bodyPr rtlCol="0" anchor="ctr"/>
-          <a:lstStyle/>
-          <a:p>
-            <a:pPr algn="ctr"/>
-          </a:p>
-        </p:txBody>
-      </p:sp>
-      <p:sp>
-        <p:nvSpPr>
-          <p:cNvPr id="7" name="TextBox 6"/>
-          <p:cNvSpPr txBox="1"/>
-          <p:nvPr/>
-        </p:nvSpPr>
-        <p:spPr>
-          <a:xfrm>
-            <a:off x="1005840" y="2011680"/>
-            <a:ext cx="10241280" cy="822960"/>
-          </a:xfrm>
-          <a:prstGeom prst="rect">
-            <a:avLst/>
-          </a:prstGeom>
-          <a:noFill/>
-        </p:spPr>
-        <p:txBody>
-          <a:bodyPr wrap="square">
-            <a:spAutoFit/>
-          </a:bodyPr>
-          <a:lstStyle/>
+          <a:bodyPr rtlCol="0" anchor="ctr" wrap="square"/>
+          <a:lstStyle/>
+          <a:p>
+            <a:pPr algn="ctr">
+              <a:defRPr b="1" sz="1500">
+                <a:solidFill>
+                  <a:srgbClr val="F2B705"/>
+                </a:solidFill>
+              </a:defRPr>
+            </a:pPr>
+            <a:r>
+              <a:t>1861 – Birth in Calamba</a:t>
+            </a:r>
+          </a:p>
           <a:p>
             <a:pPr>
-              <a:defRPr sz="1800" b="1">
-                <a:solidFill>
-                  <a:srgbClr val="F2B705"/>
+              <a:defRPr sz="1100">
+                <a:solidFill>
+                  <a:srgbClr val="F0F0F0"/>
                 </a:solidFill>
               </a:defRPr>
             </a:pPr>
             <a:r>
-              <a:t>Reject Apathy</a:t>
-            </a:r>
-          </a:p>
-          <a:p>
-            <a:pPr>
-              <a:spcBef>
-                <a:spcPts val="300"/>
-              </a:spcBef>
-              <a:defRPr sz="1300">
-                <a:solidFill>
-                  <a:srgbClr val="FFFFFF"/>
-                </a:solidFill>
-              </a:defRPr>
-            </a:pPr>
-            <a:r>
-              <a:t>The youth must remain the vibrant conscience of civil society.</a:t>
-            </a:r>
-          </a:p>
-        </p:txBody>
-      </p:sp>
-      <p:sp>
-        <p:nvSpPr>
-          <p:cNvPr id="8" name="Rounded Rectangle 7"/>
+              <a:t>Born on June 19, 1861, the seventh child of Francisco Mercado and Teodora Alonso.</a:t>
+            </a:r>
+          </a:p>
+        </p:txBody>
+      </p:sp>
+      <p:sp>
+        <p:nvSpPr>
+          <p:cNvPr id="5" name="!!Card_2"/>
           <p:cNvSpPr/>
           <p:nvPr/>
         </p:nvSpPr>
         <p:spPr>
           <a:xfrm>
-            <a:off x="731520" y="3200400"/>
-            <a:ext cx="10728655" cy="1188720"/>
+            <a:off x="4389120" y="1645920"/>
+            <a:ext cx="3291840" cy="4114800"/>
           </a:xfrm>
           <a:prstGeom prst="roundRect">
             <a:avLst/>
           </a:prstGeom>
           <a:solidFill>
-            <a:srgbClr val="183B64"/>
+            <a:srgbClr val="193A62"/>
           </a:solidFill>
           <a:ln w="19050">
             <a:solidFill>
@@ -4724,79 +4572,50 @@
           </a:fontRef>
         </p:style>
         <p:txBody>
-          <a:bodyPr rtlCol="0" anchor="ctr"/>
-          <a:lstStyle/>
-          <a:p>
-            <a:pPr algn="ctr"/>
-          </a:p>
-        </p:txBody>
-      </p:sp>
-      <p:sp>
-        <p:nvSpPr>
-          <p:cNvPr id="9" name="TextBox 8"/>
-          <p:cNvSpPr txBox="1"/>
-          <p:nvPr/>
-        </p:nvSpPr>
-        <p:spPr>
-          <a:xfrm>
-            <a:off x="1005840" y="3383280"/>
-            <a:ext cx="10241280" cy="822960"/>
-          </a:xfrm>
-          <a:prstGeom prst="rect">
-            <a:avLst/>
-          </a:prstGeom>
-          <a:noFill/>
-        </p:spPr>
-        <p:txBody>
-          <a:bodyPr wrap="square">
-            <a:spAutoFit/>
-          </a:bodyPr>
-          <a:lstStyle/>
+          <a:bodyPr rtlCol="0" anchor="ctr" wrap="square"/>
+          <a:lstStyle/>
+          <a:p>
+            <a:pPr algn="ctr">
+              <a:defRPr b="1" sz="1500">
+                <a:solidFill>
+                  <a:srgbClr val="F2B705"/>
+                </a:solidFill>
+              </a:defRPr>
+            </a:pPr>
+            <a:r>
+              <a:t>1887 – Publication of Noli</a:t>
+            </a:r>
+          </a:p>
           <a:p>
             <a:pPr>
-              <a:defRPr sz="1800" b="1">
-                <a:solidFill>
-                  <a:srgbClr val="F2B705"/>
+              <a:defRPr sz="1100">
+                <a:solidFill>
+                  <a:srgbClr val="F0F0F0"/>
                 </a:solidFill>
               </a:defRPr>
             </a:pPr>
             <a:r>
-              <a:t>Cultivate Excellence</a:t>
-            </a:r>
-          </a:p>
-          <a:p>
-            <a:pPr>
-              <a:spcBef>
-                <a:spcPts val="300"/>
-              </a:spcBef>
-              <a:defRPr sz="1300">
-                <a:solidFill>
-                  <a:srgbClr val="FFFFFF"/>
-                </a:solidFill>
-              </a:defRPr>
-            </a:pPr>
-            <a:r>
-              <a:t>National defense in the modern era is fought through technical mastery.</a:t>
-            </a:r>
-          </a:p>
-        </p:txBody>
-      </p:sp>
-      <p:sp>
-        <p:nvSpPr>
-          <p:cNvPr id="10" name="Rounded Rectangle 9"/>
+              <a:t>Berlin printing initiates the irreversible intellectual awakening of the Philippine archipelago.</a:t>
+            </a:r>
+          </a:p>
+        </p:txBody>
+      </p:sp>
+      <p:sp>
+        <p:nvSpPr>
+          <p:cNvPr id="6" name="!!Card_3"/>
           <p:cNvSpPr/>
           <p:nvPr/>
         </p:nvSpPr>
         <p:spPr>
           <a:xfrm>
-            <a:off x="731520" y="4572000"/>
-            <a:ext cx="10728655" cy="1188720"/>
+            <a:off x="8046720" y="1645920"/>
+            <a:ext cx="3291840" cy="4114800"/>
           </a:xfrm>
           <a:prstGeom prst="roundRect">
             <a:avLst/>
           </a:prstGeom>
           <a:solidFill>
-            <a:srgbClr val="183B64"/>
+            <a:srgbClr val="193A62"/>
           </a:solidFill>
           <a:ln w="19050">
             <a:solidFill>
@@ -4819,59 +4638,30 @@
           </a:fontRef>
         </p:style>
         <p:txBody>
-          <a:bodyPr rtlCol="0" anchor="ctr"/>
-          <a:lstStyle/>
-          <a:p>
-            <a:pPr algn="ctr"/>
-          </a:p>
-        </p:txBody>
-      </p:sp>
-      <p:sp>
-        <p:nvSpPr>
-          <p:cNvPr id="11" name="TextBox 10"/>
-          <p:cNvSpPr txBox="1"/>
-          <p:nvPr/>
-        </p:nvSpPr>
-        <p:spPr>
-          <a:xfrm>
-            <a:off x="1005840" y="4754880"/>
-            <a:ext cx="10241280" cy="822960"/>
-          </a:xfrm>
-          <a:prstGeom prst="rect">
-            <a:avLst/>
-          </a:prstGeom>
-          <a:noFill/>
-        </p:spPr>
-        <p:txBody>
-          <a:bodyPr wrap="square">
-            <a:spAutoFit/>
-          </a:bodyPr>
-          <a:lstStyle/>
+          <a:bodyPr rtlCol="0" anchor="ctr" wrap="square"/>
+          <a:lstStyle/>
+          <a:p>
+            <a:pPr algn="ctr">
+              <a:defRPr b="1" sz="1500">
+                <a:solidFill>
+                  <a:srgbClr val="F2B705"/>
+                </a:solidFill>
+              </a:defRPr>
+            </a:pPr>
+            <a:r>
+              <a:t>1896 – Martyrdom at Bagumbayan</a:t>
+            </a:r>
+          </a:p>
           <a:p>
             <a:pPr>
-              <a:defRPr sz="1800" b="1">
-                <a:solidFill>
-                  <a:srgbClr val="F2B705"/>
+              <a:defRPr sz="1100">
+                <a:solidFill>
+                  <a:srgbClr val="F0F0F0"/>
                 </a:solidFill>
               </a:defRPr>
             </a:pPr>
             <a:r>
-              <a:t>Love of Country in Deed</a:t>
-            </a:r>
-          </a:p>
-          <a:p>
-            <a:pPr>
-              <a:spcBef>
-                <a:spcPts val="300"/>
-              </a:spcBef>
-              <a:defRPr sz="1300">
-                <a:solidFill>
-                  <a:srgbClr val="FFFFFF"/>
-                </a:solidFill>
-              </a:defRPr>
-            </a:pPr>
-            <a:r>
-              <a:t>Patriotism is measured by daily community contribution, not empty slogans.</a:t>
+              <a:t>Executed on December 30, 1896; his death ignited the ultimate triumph of the Philippine Revolution.</a:t>
             </a:r>
           </a:p>
         </p:txBody>
@@ -4888,7 +4678,7 @@
 </file>
 
 <file path=ppt/slides/slide11.xml><?xml version="1.0" encoding="utf-8"?>
-<p:sld xmlns:a="http://schemas.openxmlformats.org/drawingml/2006/main" xmlns:p="http://schemas.openxmlformats.org/presentationml/2006/main" xmlns:r="http://schemas.openxmlformats.org/officeDocument/2006/relationships">
+<p:sld xmlns:p14="http://schemas.microsoft.com/office/powerpoint/2010/main" xmlns:a="http://schemas.openxmlformats.org/drawingml/2006/main" xmlns:p="http://schemas.openxmlformats.org/presentationml/2006/main" xmlns:r="http://schemas.openxmlformats.org/officeDocument/2006/relationships">
   <p:cSld>
     <p:spTree>
       <p:nvGrpSpPr>
@@ -4940,16 +4730,40 @@
           </a:p>
         </p:txBody>
       </p:sp>
-      <p:sp>
-        <p:nvSpPr>
-          <p:cNvPr id="3" name="TextBox 2"/>
+      <p:pic>
+        <p:nvPicPr>
+          <p:cNvPr id="3" name="!!Hero_Image" descr="rizal_closing.png"/>
+          <p:cNvPicPr>
+            <a:picLocks noChangeAspect="1"/>
+          </p:cNvPicPr>
+          <p:nvPr/>
+        </p:nvPicPr>
+        <p:blipFill>
+          <a:blip r:embed="rId2"/>
+          <a:stretch>
+            <a:fillRect/>
+          </a:stretch>
+        </p:blipFill>
+        <p:spPr>
+          <a:xfrm>
+            <a:off x="6217920" y="731520"/>
+            <a:ext cx="5303520" cy="5394960"/>
+          </a:xfrm>
+          <a:prstGeom prst="rect">
+            <a:avLst/>
+          </a:prstGeom>
+        </p:spPr>
+      </p:pic>
+      <p:sp>
+        <p:nvSpPr>
+          <p:cNvPr id="4" name="!!Title_Card"/>
           <p:cNvSpPr txBox="1"/>
           <p:nvPr/>
         </p:nvSpPr>
         <p:spPr>
           <a:xfrm>
-            <a:off x="731520" y="365760"/>
-            <a:ext cx="10058400" cy="365760"/>
+            <a:off x="731520" y="1463040"/>
+            <a:ext cx="5303520" cy="4114800"/>
           </a:xfrm>
           <a:prstGeom prst="rect">
             <a:avLst/>
@@ -4957,812 +4771,57 @@
           <a:noFill/>
         </p:spPr>
         <p:txBody>
-          <a:bodyPr wrap="none">
-            <a:spAutoFit/>
-          </a:bodyPr>
-          <a:lstStyle/>
-          <a:p>
-            <a:pPr>
-              <a:defRPr sz="1100" b="1">
-                <a:solidFill>
-                  <a:srgbClr val="F2B705"/>
-                </a:solidFill>
-              </a:defRPr>
-            </a:pPr>
-            <a:r>
-              <a:t>SCHOLARLY DOCUMENTATION</a:t>
-            </a:r>
-          </a:p>
-        </p:txBody>
-      </p:sp>
-      <p:sp>
-        <p:nvSpPr>
-          <p:cNvPr id="4" name="TextBox 3"/>
-          <p:cNvSpPr txBox="1"/>
-          <p:nvPr/>
-        </p:nvSpPr>
-        <p:spPr>
-          <a:xfrm>
-            <a:off x="731520" y="685800"/>
-            <a:ext cx="10515600" cy="731520"/>
-          </a:xfrm>
-          <a:prstGeom prst="rect">
-            <a:avLst/>
-          </a:prstGeom>
-          <a:noFill/>
-        </p:spPr>
-        <p:txBody>
-          <a:bodyPr wrap="none">
-            <a:spAutoFit/>
-          </a:bodyPr>
-          <a:lstStyle/>
-          <a:p>
-            <a:pPr>
-              <a:defRPr sz="2600" b="1">
-                <a:solidFill>
-                  <a:srgbClr val="FFFFFF"/>
-                </a:solidFill>
-              </a:defRPr>
-            </a:pPr>
-            <a:r>
-              <a:t>Historical References &amp; Primary Sources</a:t>
-            </a:r>
-          </a:p>
-        </p:txBody>
-      </p:sp>
-      <p:sp>
-        <p:nvSpPr>
-          <p:cNvPr id="5" name="TextBox 4"/>
-          <p:cNvSpPr txBox="1"/>
-          <p:nvPr/>
-        </p:nvSpPr>
-        <p:spPr>
-          <a:xfrm>
-            <a:off x="731520" y="6400800"/>
-            <a:ext cx="10728655" cy="320040"/>
-          </a:xfrm>
-          <a:prstGeom prst="rect">
-            <a:avLst/>
-          </a:prstGeom>
-          <a:noFill/>
-        </p:spPr>
-        <p:txBody>
-          <a:bodyPr wrap="none">
-            <a:spAutoFit/>
-          </a:bodyPr>
-          <a:lstStyle/>
-          <a:p>
-            <a:pPr>
-              <a:defRPr sz="900">
-                <a:solidFill>
-                  <a:srgbClr val="93C5FD"/>
-                </a:solidFill>
-              </a:defRPr>
-            </a:pPr>
-            <a:r>
-              <a:t>STI West Negros University  •  Jhon Paulo V. Gascon  •  Slide 11 of 11</a:t>
-            </a:r>
-          </a:p>
-        </p:txBody>
-      </p:sp>
-      <p:sp>
-        <p:nvSpPr>
-          <p:cNvPr id="6" name="Rounded Rectangle 5"/>
-          <p:cNvSpPr/>
-          <p:nvPr/>
-        </p:nvSpPr>
-        <p:spPr>
-          <a:xfrm>
-            <a:off x="731520" y="1828800"/>
-            <a:ext cx="10728655" cy="4114800"/>
-          </a:xfrm>
-          <a:prstGeom prst="roundRect">
-            <a:avLst/>
-          </a:prstGeom>
-          <a:solidFill>
-            <a:srgbClr val="183B64"/>
-          </a:solidFill>
-          <a:ln w="12700">
-            <a:solidFill>
-              <a:srgbClr val="93C5FD"/>
-            </a:solidFill>
-          </a:ln>
-        </p:spPr>
-        <p:style>
-          <a:lnRef idx="1">
-            <a:schemeClr val="accent1"/>
-          </a:lnRef>
-          <a:fillRef idx="3">
-            <a:schemeClr val="accent1"/>
-          </a:fillRef>
-          <a:effectRef idx="2">
-            <a:schemeClr val="accent1"/>
-          </a:effectRef>
-          <a:fontRef idx="minor">
-            <a:schemeClr val="lt1"/>
-          </a:fontRef>
-        </p:style>
-        <p:txBody>
-          <a:bodyPr rtlCol="0" anchor="ctr"/>
-          <a:lstStyle/>
-          <a:p>
-            <a:pPr algn="ctr"/>
-          </a:p>
-        </p:txBody>
-      </p:sp>
-      <p:sp>
-        <p:nvSpPr>
-          <p:cNvPr id="7" name="TextBox 6"/>
-          <p:cNvSpPr txBox="1"/>
-          <p:nvPr/>
-        </p:nvSpPr>
-        <p:spPr>
-          <a:xfrm>
-            <a:off x="1097280" y="2103120"/>
-            <a:ext cx="10058400" cy="3566160"/>
-          </a:xfrm>
-          <a:prstGeom prst="rect">
-            <a:avLst/>
-          </a:prstGeom>
-          <a:noFill/>
-        </p:spPr>
-        <p:txBody>
           <a:bodyPr wrap="square">
             <a:spAutoFit/>
           </a:bodyPr>
           <a:lstStyle/>
           <a:p>
             <a:pPr>
-              <a:spcBef>
-                <a:spcPts val="1400"/>
-              </a:spcBef>
-              <a:defRPr sz="1300">
+              <a:defRPr sz="3200" b="1">
                 <a:solidFill>
                   <a:srgbClr val="FFFFFF"/>
                 </a:solidFill>
               </a:defRPr>
             </a:pPr>
             <a:r>
-              <a:t>•  Guerrero, L. M. (1963). The first Filipino: A biography of Jose Rizal. National Historical Commission of the Philippines.</a:t>
+              <a:t>The Immortal Legacy of Jose Rizal</a:t>
             </a:r>
           </a:p>
           <a:p>
             <a:pPr>
-              <a:spcBef>
-                <a:spcPts val="1400"/>
-              </a:spcBef>
-              <a:defRPr sz="1300">
-                <a:solidFill>
-                  <a:srgbClr val="FFFFFF"/>
+              <a:defRPr sz="1400">
+                <a:solidFill>
+                  <a:srgbClr val="F2B705"/>
                 </a:solidFill>
               </a:defRPr>
             </a:pPr>
             <a:r>
-              <a:t>•  Rizal, J. (1887). Noli me tangere. Berlin: Berliner Buchdruckerei-Actien-Gesellschaft.</a:t>
-            </a:r>
-          </a:p>
-          <a:p>
+              <a:t>The Youth is the Hope of the Fatherland</a:t>
+            </a:r>
+          </a:p>
+          <a:p>
+            <a:br/>
             <a:pPr>
-              <a:spcBef>
-                <a:spcPts val="1400"/>
-              </a:spcBef>
-              <a:defRPr sz="1300">
-                <a:solidFill>
-                  <a:srgbClr val="FFFFFF"/>
+              <a:defRPr sz="1000">
+                <a:solidFill>
+                  <a:srgbClr val="96AABE"/>
                 </a:solidFill>
               </a:defRPr>
             </a:pPr>
             <a:r>
-              <a:t>•  Schumacher, J. N. (1997). The propaganda movement: 1880–1895. Ateneo de Manila University Press.</a:t>
-            </a:r>
-          </a:p>
-        </p:txBody>
-      </p:sp>
-    </p:spTree>
-  </p:cSld>
-  <p:clrMapOvr>
-    <a:masterClrMapping/>
-  </p:clrMapOvr>
-  <p:transition spd="slow">
-    <p:fade/>
-  </p:transition>
-</p:sld>
-</file>
-
-<file path=ppt/slides/slide2.xml><?xml version="1.0" encoding="utf-8"?>
-<p:sld xmlns:a="http://schemas.openxmlformats.org/drawingml/2006/main" xmlns:p="http://schemas.openxmlformats.org/presentationml/2006/main" xmlns:r="http://schemas.openxmlformats.org/officeDocument/2006/relationships">
-  <p:cSld>
-    <p:spTree>
-      <p:nvGrpSpPr>
-        <p:cNvPr id="1" name=""/>
-        <p:cNvGrpSpPr/>
-        <p:nvPr/>
-      </p:nvGrpSpPr>
-      <p:grpSpPr/>
-      <p:sp>
-        <p:nvSpPr>
-          <p:cNvPr id="2" name="Rectangle 1"/>
-          <p:cNvSpPr/>
-          <p:nvPr/>
-        </p:nvSpPr>
-        <p:spPr>
-          <a:xfrm>
-            <a:off x="0" y="0"/>
-            <a:ext cx="12191695" cy="6858000"/>
-          </a:xfrm>
-          <a:prstGeom prst="rect">
-            <a:avLst/>
-          </a:prstGeom>
-          <a:solidFill>
-            <a:srgbClr val="0F2A4A"/>
-          </a:solidFill>
-          <a:ln>
-            <a:noFill/>
-          </a:ln>
-        </p:spPr>
-        <p:style>
-          <a:lnRef idx="1">
-            <a:schemeClr val="accent1"/>
-          </a:lnRef>
-          <a:fillRef idx="3">
-            <a:schemeClr val="accent1"/>
-          </a:fillRef>
-          <a:effectRef idx="2">
-            <a:schemeClr val="accent1"/>
-          </a:effectRef>
-          <a:fontRef idx="minor">
-            <a:schemeClr val="lt1"/>
-          </a:fontRef>
-        </p:style>
-        <p:txBody>
-          <a:bodyPr rtlCol="0" anchor="ctr"/>
-          <a:lstStyle/>
-          <a:p>
-            <a:pPr algn="ctr"/>
-          </a:p>
-        </p:txBody>
-      </p:sp>
-      <p:sp>
-        <p:nvSpPr>
-          <p:cNvPr id="3" name="TextBox 2"/>
-          <p:cNvSpPr txBox="1"/>
-          <p:nvPr/>
-        </p:nvSpPr>
-        <p:spPr>
-          <a:xfrm>
-            <a:off x="731520" y="365760"/>
-            <a:ext cx="10058400" cy="365760"/>
-          </a:xfrm>
-          <a:prstGeom prst="rect">
-            <a:avLst/>
-          </a:prstGeom>
-          <a:noFill/>
-        </p:spPr>
-        <p:txBody>
-          <a:bodyPr wrap="none">
-            <a:spAutoFit/>
-          </a:bodyPr>
-          <a:lstStyle/>
-          <a:p>
-            <a:pPr>
-              <a:defRPr sz="1100" b="1">
-                <a:solidFill>
-                  <a:srgbClr val="F2B705"/>
-                </a:solidFill>
-              </a:defRPr>
-            </a:pPr>
-            <a:r>
-              <a:t>STRUCTURE &amp; OVERVIEW</a:t>
-            </a:r>
-          </a:p>
-        </p:txBody>
-      </p:sp>
-      <p:sp>
-        <p:nvSpPr>
-          <p:cNvPr id="4" name="TextBox 3"/>
-          <p:cNvSpPr txBox="1"/>
-          <p:nvPr/>
-        </p:nvSpPr>
-        <p:spPr>
-          <a:xfrm>
-            <a:off x="731520" y="685800"/>
-            <a:ext cx="10515600" cy="731520"/>
-          </a:xfrm>
-          <a:prstGeom prst="rect">
-            <a:avLst/>
-          </a:prstGeom>
-          <a:noFill/>
-        </p:spPr>
-        <p:txBody>
-          <a:bodyPr wrap="none">
-            <a:spAutoFit/>
-          </a:bodyPr>
-          <a:lstStyle/>
-          <a:p>
-            <a:pPr>
-              <a:defRPr sz="2600" b="1">
-                <a:solidFill>
-                  <a:srgbClr val="FFFFFF"/>
-                </a:solidFill>
-              </a:defRPr>
-            </a:pPr>
-            <a:r>
-              <a:t>Presentation Roadmap</a:t>
-            </a:r>
-          </a:p>
-        </p:txBody>
-      </p:sp>
-      <p:sp>
-        <p:nvSpPr>
-          <p:cNvPr id="5" name="TextBox 4"/>
-          <p:cNvSpPr txBox="1"/>
-          <p:nvPr/>
-        </p:nvSpPr>
-        <p:spPr>
-          <a:xfrm>
-            <a:off x="731520" y="6400800"/>
-            <a:ext cx="10728655" cy="320040"/>
-          </a:xfrm>
-          <a:prstGeom prst="rect">
-            <a:avLst/>
-          </a:prstGeom>
-          <a:noFill/>
-        </p:spPr>
-        <p:txBody>
-          <a:bodyPr wrap="none">
-            <a:spAutoFit/>
-          </a:bodyPr>
-          <a:lstStyle/>
-          <a:p>
-            <a:pPr>
-              <a:defRPr sz="900">
-                <a:solidFill>
-                  <a:srgbClr val="93C5FD"/>
-                </a:solidFill>
-              </a:defRPr>
-            </a:pPr>
-            <a:r>
-              <a:t>STI West Negros University  •  Jhon Paulo V. Gascon  •  Slide 2 of 11</a:t>
-            </a:r>
-          </a:p>
-        </p:txBody>
-      </p:sp>
-      <p:sp>
-        <p:nvSpPr>
-          <p:cNvPr id="6" name="Rounded Rectangle 5"/>
-          <p:cNvSpPr/>
-          <p:nvPr/>
-        </p:nvSpPr>
-        <p:spPr>
-          <a:xfrm>
-            <a:off x="731520" y="1828800"/>
-            <a:ext cx="2514600" cy="4114800"/>
-          </a:xfrm>
-          <a:prstGeom prst="roundRect">
-            <a:avLst/>
-          </a:prstGeom>
-          <a:solidFill>
-            <a:srgbClr val="183B64"/>
-          </a:solidFill>
-          <a:ln w="19050">
-            <a:solidFill>
-              <a:srgbClr val="F2B705"/>
-            </a:solidFill>
-          </a:ln>
-        </p:spPr>
-        <p:style>
-          <a:lnRef idx="1">
-            <a:schemeClr val="accent1"/>
-          </a:lnRef>
-          <a:fillRef idx="3">
-            <a:schemeClr val="accent1"/>
-          </a:fillRef>
-          <a:effectRef idx="2">
-            <a:schemeClr val="accent1"/>
-          </a:effectRef>
-          <a:fontRef idx="minor">
-            <a:schemeClr val="lt1"/>
-          </a:fontRef>
-        </p:style>
-        <p:txBody>
-          <a:bodyPr rtlCol="0" anchor="ctr"/>
-          <a:lstStyle/>
-          <a:p>
-            <a:pPr algn="ctr"/>
-          </a:p>
-        </p:txBody>
-      </p:sp>
-      <p:sp>
-        <p:nvSpPr>
-          <p:cNvPr id="7" name="TextBox 6"/>
-          <p:cNvSpPr txBox="1"/>
-          <p:nvPr/>
-        </p:nvSpPr>
-        <p:spPr>
-          <a:xfrm>
-            <a:off x="914400" y="2103120"/>
-            <a:ext cx="2148840" cy="3474720"/>
-          </a:xfrm>
-          <a:prstGeom prst="rect">
-            <a:avLst/>
-          </a:prstGeom>
-          <a:noFill/>
-        </p:spPr>
-        <p:txBody>
-          <a:bodyPr wrap="square">
-            <a:spAutoFit/>
-          </a:bodyPr>
-          <a:lstStyle/>
-          <a:p>
-            <a:pPr>
-              <a:defRPr sz="3600" b="1">
-                <a:solidFill>
-                  <a:srgbClr val="F2B705"/>
-                </a:solidFill>
-              </a:defRPr>
-            </a:pPr>
-            <a:r>
-              <a:t>01</a:t>
-            </a:r>
-          </a:p>
-          <a:p>
-            <a:pPr>
-              <a:spcBef>
-                <a:spcPts val="1400"/>
-              </a:spcBef>
-              <a:defRPr sz="1600" b="1">
-                <a:solidFill>
-                  <a:srgbClr val="FFFFFF"/>
-                </a:solidFill>
-              </a:defRPr>
-            </a:pPr>
-            <a:r>
-              <a:t>Early Life &amp; Formative Years</a:t>
-            </a:r>
-          </a:p>
-          <a:p>
-            <a:pPr>
-              <a:spcBef>
-                <a:spcPts val="1000"/>
-              </a:spcBef>
-              <a:defRPr sz="1300">
-                <a:solidFill>
-                  <a:srgbClr val="93C5FD"/>
-                </a:solidFill>
-              </a:defRPr>
-            </a:pPr>
-            <a:r>
-              <a:t>Calamba roots and European academic exposure</a:t>
-            </a:r>
-          </a:p>
-        </p:txBody>
-      </p:sp>
-      <p:sp>
-        <p:nvSpPr>
-          <p:cNvPr id="8" name="Rounded Rectangle 7"/>
-          <p:cNvSpPr/>
-          <p:nvPr/>
-        </p:nvSpPr>
-        <p:spPr>
-          <a:xfrm>
-            <a:off x="3429000" y="1828800"/>
-            <a:ext cx="2514600" cy="4114800"/>
-          </a:xfrm>
-          <a:prstGeom prst="roundRect">
-            <a:avLst/>
-          </a:prstGeom>
-          <a:solidFill>
-            <a:srgbClr val="183B64"/>
-          </a:solidFill>
-          <a:ln w="19050">
-            <a:solidFill>
-              <a:srgbClr val="F2B705"/>
-            </a:solidFill>
-          </a:ln>
-        </p:spPr>
-        <p:style>
-          <a:lnRef idx="1">
-            <a:schemeClr val="accent1"/>
-          </a:lnRef>
-          <a:fillRef idx="3">
-            <a:schemeClr val="accent1"/>
-          </a:fillRef>
-          <a:effectRef idx="2">
-            <a:schemeClr val="accent1"/>
-          </a:effectRef>
-          <a:fontRef idx="minor">
-            <a:schemeClr val="lt1"/>
-          </a:fontRef>
-        </p:style>
-        <p:txBody>
-          <a:bodyPr rtlCol="0" anchor="ctr"/>
-          <a:lstStyle/>
-          <a:p>
-            <a:pPr algn="ctr"/>
-          </a:p>
-        </p:txBody>
-      </p:sp>
-      <p:sp>
-        <p:nvSpPr>
-          <p:cNvPr id="9" name="TextBox 8"/>
-          <p:cNvSpPr txBox="1"/>
-          <p:nvPr/>
-        </p:nvSpPr>
-        <p:spPr>
-          <a:xfrm>
-            <a:off x="3611880" y="2103120"/>
-            <a:ext cx="2148840" cy="3474720"/>
-          </a:xfrm>
-          <a:prstGeom prst="rect">
-            <a:avLst/>
-          </a:prstGeom>
-          <a:noFill/>
-        </p:spPr>
-        <p:txBody>
-          <a:bodyPr wrap="square">
-            <a:spAutoFit/>
-          </a:bodyPr>
-          <a:lstStyle/>
-          <a:p>
-            <a:pPr>
-              <a:defRPr sz="3600" b="1">
-                <a:solidFill>
-                  <a:srgbClr val="F2B705"/>
-                </a:solidFill>
-              </a:defRPr>
-            </a:pPr>
-            <a:r>
-              <a:t>02</a:t>
-            </a:r>
-          </a:p>
-          <a:p>
-            <a:pPr>
-              <a:spcBef>
-                <a:spcPts val="1400"/>
-              </a:spcBef>
-              <a:defRPr sz="1600" b="1">
-                <a:solidFill>
-                  <a:srgbClr val="FFFFFF"/>
-                </a:solidFill>
-              </a:defRPr>
-            </a:pPr>
-            <a:r>
-              <a:t>The Masterpiece Novels</a:t>
-            </a:r>
-          </a:p>
-          <a:p>
-            <a:pPr>
-              <a:spcBef>
-                <a:spcPts val="1000"/>
-              </a:spcBef>
-              <a:defRPr sz="1300">
-                <a:solidFill>
-                  <a:srgbClr val="93C5FD"/>
-                </a:solidFill>
-              </a:defRPr>
-            </a:pPr>
-            <a:r>
-              <a:t>Noli Me Tangere and El Filibusterismo</a:t>
-            </a:r>
-          </a:p>
-        </p:txBody>
-      </p:sp>
-      <p:sp>
-        <p:nvSpPr>
-          <p:cNvPr id="10" name="Rounded Rectangle 9"/>
-          <p:cNvSpPr/>
-          <p:nvPr/>
-        </p:nvSpPr>
-        <p:spPr>
-          <a:xfrm>
-            <a:off x="6126480" y="1828800"/>
-            <a:ext cx="2514600" cy="4114800"/>
-          </a:xfrm>
-          <a:prstGeom prst="roundRect">
-            <a:avLst/>
-          </a:prstGeom>
-          <a:solidFill>
-            <a:srgbClr val="183B64"/>
-          </a:solidFill>
-          <a:ln w="19050">
-            <a:solidFill>
-              <a:srgbClr val="F2B705"/>
-            </a:solidFill>
-          </a:ln>
-        </p:spPr>
-        <p:style>
-          <a:lnRef idx="1">
-            <a:schemeClr val="accent1"/>
-          </a:lnRef>
-          <a:fillRef idx="3">
-            <a:schemeClr val="accent1"/>
-          </a:fillRef>
-          <a:effectRef idx="2">
-            <a:schemeClr val="accent1"/>
-          </a:effectRef>
-          <a:fontRef idx="minor">
-            <a:schemeClr val="lt1"/>
-          </a:fontRef>
-        </p:style>
-        <p:txBody>
-          <a:bodyPr rtlCol="0" anchor="ctr"/>
-          <a:lstStyle/>
-          <a:p>
-            <a:pPr algn="ctr"/>
-          </a:p>
-        </p:txBody>
-      </p:sp>
-      <p:sp>
-        <p:nvSpPr>
-          <p:cNvPr id="11" name="TextBox 10"/>
-          <p:cNvSpPr txBox="1"/>
-          <p:nvPr/>
-        </p:nvSpPr>
-        <p:spPr>
-          <a:xfrm>
-            <a:off x="6309360" y="2103120"/>
-            <a:ext cx="2148840" cy="3474720"/>
-          </a:xfrm>
-          <a:prstGeom prst="rect">
-            <a:avLst/>
-          </a:prstGeom>
-          <a:noFill/>
-        </p:spPr>
-        <p:txBody>
-          <a:bodyPr wrap="square">
-            <a:spAutoFit/>
-          </a:bodyPr>
-          <a:lstStyle/>
-          <a:p>
-            <a:pPr>
-              <a:defRPr sz="3600" b="1">
-                <a:solidFill>
-                  <a:srgbClr val="F2B705"/>
-                </a:solidFill>
-              </a:defRPr>
-            </a:pPr>
-            <a:r>
-              <a:t>03</a:t>
-            </a:r>
-          </a:p>
-          <a:p>
-            <a:pPr>
-              <a:spcBef>
-                <a:spcPts val="1400"/>
-              </a:spcBef>
-              <a:defRPr sz="1600" b="1">
-                <a:solidFill>
-                  <a:srgbClr val="FFFFFF"/>
-                </a:solidFill>
-              </a:defRPr>
-            </a:pPr>
-            <a:r>
-              <a:t>Civic Reform in Exile</a:t>
-            </a:r>
-          </a:p>
-          <a:p>
-            <a:pPr>
-              <a:spcBef>
-                <a:spcPts val="1000"/>
-              </a:spcBef>
-              <a:defRPr sz="1300">
-                <a:solidFill>
-                  <a:srgbClr val="93C5FD"/>
-                </a:solidFill>
-              </a:defRPr>
-            </a:pPr>
-            <a:r>
-              <a:t>La Liga Filipina and community building in Dapitan</a:t>
-            </a:r>
-          </a:p>
-        </p:txBody>
-      </p:sp>
-      <p:sp>
-        <p:nvSpPr>
-          <p:cNvPr id="12" name="Rounded Rectangle 11"/>
-          <p:cNvSpPr/>
-          <p:nvPr/>
-        </p:nvSpPr>
-        <p:spPr>
-          <a:xfrm>
-            <a:off x="8823960" y="1828800"/>
-            <a:ext cx="2514600" cy="4114800"/>
-          </a:xfrm>
-          <a:prstGeom prst="roundRect">
-            <a:avLst/>
-          </a:prstGeom>
-          <a:solidFill>
-            <a:srgbClr val="183B64"/>
-          </a:solidFill>
-          <a:ln w="19050">
-            <a:solidFill>
-              <a:srgbClr val="F2B705"/>
-            </a:solidFill>
-          </a:ln>
-        </p:spPr>
-        <p:style>
-          <a:lnRef idx="1">
-            <a:schemeClr val="accent1"/>
-          </a:lnRef>
-          <a:fillRef idx="3">
-            <a:schemeClr val="accent1"/>
-          </a:fillRef>
-          <a:effectRef idx="2">
-            <a:schemeClr val="accent1"/>
-          </a:effectRef>
-          <a:fontRef idx="minor">
-            <a:schemeClr val="lt1"/>
-          </a:fontRef>
-        </p:style>
-        <p:txBody>
-          <a:bodyPr rtlCol="0" anchor="ctr"/>
-          <a:lstStyle/>
-          <a:p>
-            <a:pPr algn="ctr"/>
-          </a:p>
-        </p:txBody>
-      </p:sp>
-      <p:sp>
-        <p:nvSpPr>
-          <p:cNvPr id="13" name="TextBox 12"/>
-          <p:cNvSpPr txBox="1"/>
-          <p:nvPr/>
-        </p:nvSpPr>
-        <p:spPr>
-          <a:xfrm>
-            <a:off x="9006840" y="2103120"/>
-            <a:ext cx="2148840" cy="3474720"/>
-          </a:xfrm>
-          <a:prstGeom prst="rect">
-            <a:avLst/>
-          </a:prstGeom>
-          <a:noFill/>
-        </p:spPr>
-        <p:txBody>
-          <a:bodyPr wrap="square">
-            <a:spAutoFit/>
-          </a:bodyPr>
-          <a:lstStyle/>
-          <a:p>
-            <a:pPr>
-              <a:defRPr sz="3600" b="1">
-                <a:solidFill>
-                  <a:srgbClr val="F2B705"/>
-                </a:solidFill>
-              </a:defRPr>
-            </a:pPr>
-            <a:r>
-              <a:t>04</a:t>
-            </a:r>
-          </a:p>
-          <a:p>
-            <a:pPr>
-              <a:spcBef>
-                <a:spcPts val="1400"/>
-              </a:spcBef>
-              <a:defRPr sz="1600" b="1">
-                <a:solidFill>
-                  <a:srgbClr val="FFFFFF"/>
-                </a:solidFill>
-              </a:defRPr>
-            </a:pPr>
-            <a:r>
-              <a:t>Martyrdom &amp; Living Legacy</a:t>
-            </a:r>
-          </a:p>
-          <a:p>
-            <a:pPr>
-              <a:spcBef>
-                <a:spcPts val="1000"/>
-              </a:spcBef>
-              <a:defRPr sz="1300">
-                <a:solidFill>
-                  <a:srgbClr val="93C5FD"/>
-                </a:solidFill>
-              </a:defRPr>
-            </a:pPr>
-            <a:r>
-              <a:t>Bagumbayan execution and modern relevance</a:t>
+              <a:t>Image &amp; Academic Credits:</a:t>
+            </a:r>
+            <a:br/>
+            <a:r>
+              <a:t>• Visual Assets: Custom 3D renders &amp; high-res vector graphics.</a:t>
+            </a:r>
+            <a:br/>
+            <a:r>
+              <a:t>• Research Citations: APA 7th academic standards.</a:t>
+            </a:r>
+            <a:br/>
+            <a:r>
+              <a:t>• STI West Negros University • BSIT Program 2026–2027</a:t>
             </a:r>
           </a:p>
         </p:txBody>
@@ -5778,8 +4837,8 @@
 </p:sld>
 </file>
 
-<file path=ppt/slides/slide3.xml><?xml version="1.0" encoding="utf-8"?>
-<p:sld xmlns:a="http://schemas.openxmlformats.org/drawingml/2006/main" xmlns:p="http://schemas.openxmlformats.org/presentationml/2006/main" xmlns:r="http://schemas.openxmlformats.org/officeDocument/2006/relationships">
+<file path=ppt/slides/slide2.xml><?xml version="1.0" encoding="utf-8"?>
+<p:sld xmlns:p14="http://schemas.microsoft.com/office/powerpoint/2010/main" xmlns:a="http://schemas.openxmlformats.org/drawingml/2006/main" xmlns:p="http://schemas.openxmlformats.org/presentationml/2006/main" xmlns:r="http://schemas.openxmlformats.org/officeDocument/2006/relationships">
   <p:cSld>
     <p:spTree>
       <p:nvGrpSpPr>
@@ -5839,8 +4898,8 @@
         </p:nvSpPr>
         <p:spPr>
           <a:xfrm>
-            <a:off x="731520" y="365760"/>
-            <a:ext cx="10058400" cy="365760"/>
+            <a:off x="731520" y="457200"/>
+            <a:ext cx="10698480" cy="1005840"/>
           </a:xfrm>
           <a:prstGeom prst="rect">
             <a:avLst/>
@@ -5848,7 +4907,7 @@
           <a:noFill/>
         </p:spPr>
         <p:txBody>
-          <a:bodyPr wrap="none">
+          <a:bodyPr wrap="square">
             <a:spAutoFit/>
           </a:bodyPr>
           <a:lstStyle/>
@@ -5861,101 +4920,67 @@
               </a:defRPr>
             </a:pPr>
             <a:r>
-              <a:t>KEY TAKEAWAY</a:t>
-            </a:r>
-          </a:p>
-        </p:txBody>
-      </p:sp>
-      <p:sp>
-        <p:nvSpPr>
-          <p:cNvPr id="4" name="TextBox 3"/>
-          <p:cNvSpPr txBox="1"/>
+              <a:t>FORMATIVE YEARS</a:t>
+            </a:r>
+          </a:p>
+          <a:p>
+            <a:pPr>
+              <a:defRPr sz="2400" b="1">
+                <a:solidFill>
+                  <a:srgbClr val="FFFFFF"/>
+                </a:solidFill>
+              </a:defRPr>
+            </a:pPr>
+            <a:r>
+              <a:t>Calamba Roots &amp; Early Foundations</a:t>
+            </a:r>
+          </a:p>
+        </p:txBody>
+      </p:sp>
+      <p:pic>
+        <p:nvPicPr>
+          <p:cNvPr id="4" name="!!Content_Image" descr="rizal_youth.png"/>
+          <p:cNvPicPr>
+            <a:picLocks noChangeAspect="1"/>
+          </p:cNvPicPr>
           <p:nvPr/>
-        </p:nvSpPr>
-        <p:spPr>
-          <a:xfrm>
-            <a:off x="731520" y="685800"/>
-            <a:ext cx="10515600" cy="731520"/>
+        </p:nvPicPr>
+        <p:blipFill>
+          <a:blip r:embed="rId2"/>
+          <a:stretch>
+            <a:fillRect/>
+          </a:stretch>
+        </p:blipFill>
+        <p:spPr>
+          <a:xfrm>
+            <a:off x="731520" y="1645920"/>
+            <a:ext cx="5029200" cy="4389120"/>
           </a:xfrm>
           <a:prstGeom prst="rect">
             <a:avLst/>
           </a:prstGeom>
-          <a:noFill/>
-        </p:spPr>
-        <p:txBody>
-          <a:bodyPr wrap="none">
-            <a:spAutoFit/>
-          </a:bodyPr>
-          <a:lstStyle/>
-          <a:p>
-            <a:pPr>
-              <a:defRPr sz="2600" b="1">
-                <a:solidFill>
-                  <a:srgbClr val="FFFFFF"/>
-                </a:solidFill>
-              </a:defRPr>
-            </a:pPr>
-            <a:r>
-              <a:t>Core Conceptual Thesis</a:t>
-            </a:r>
-          </a:p>
-        </p:txBody>
-      </p:sp>
-      <p:sp>
-        <p:nvSpPr>
-          <p:cNvPr id="5" name="TextBox 4"/>
-          <p:cNvSpPr txBox="1"/>
-          <p:nvPr/>
-        </p:nvSpPr>
-        <p:spPr>
-          <a:xfrm>
-            <a:off x="731520" y="6400800"/>
-            <a:ext cx="10728655" cy="320040"/>
-          </a:xfrm>
-          <a:prstGeom prst="rect">
-            <a:avLst/>
-          </a:prstGeom>
-          <a:noFill/>
-        </p:spPr>
-        <p:txBody>
-          <a:bodyPr wrap="none">
-            <a:spAutoFit/>
-          </a:bodyPr>
-          <a:lstStyle/>
-          <a:p>
-            <a:pPr>
-              <a:defRPr sz="900">
-                <a:solidFill>
-                  <a:srgbClr val="93C5FD"/>
-                </a:solidFill>
-              </a:defRPr>
-            </a:pPr>
-            <a:r>
-              <a:t>STI West Negros University  •  Jhon Paulo V. Gascon  •  Slide 3 of 11</a:t>
-            </a:r>
-          </a:p>
-        </p:txBody>
-      </p:sp>
-      <p:sp>
-        <p:nvSpPr>
-          <p:cNvPr id="6" name="Rounded Rectangle 5"/>
+        </p:spPr>
+      </p:pic>
+      <p:sp>
+        <p:nvSpPr>
+          <p:cNvPr id="5" name="!!Card_1"/>
           <p:cNvSpPr/>
           <p:nvPr/>
         </p:nvSpPr>
         <p:spPr>
           <a:xfrm>
-            <a:off x="731520" y="1828800"/>
-            <a:ext cx="10728655" cy="4114800"/>
+            <a:off x="6126480" y="1645920"/>
+            <a:ext cx="5303520" cy="1280160"/>
           </a:xfrm>
           <a:prstGeom prst="roundRect">
             <a:avLst/>
           </a:prstGeom>
           <a:solidFill>
-            <a:srgbClr val="183B64"/>
+            <a:srgbClr val="193A62"/>
           </a:solidFill>
-          <a:ln w="25400">
+          <a:ln w="12700">
             <a:solidFill>
-              <a:srgbClr val="3E7CB1"/>
+              <a:srgbClr val="F2B705"/>
             </a:solidFill>
           </a:ln>
         </p:spPr>
@@ -5974,6 +4999,232 @@
           </a:fontRef>
         </p:style>
         <p:txBody>
+          <a:bodyPr rtlCol="0" anchor="ctr" wrap="square"/>
+          <a:lstStyle/>
+          <a:p>
+            <a:pPr algn="ctr">
+              <a:defRPr b="1" sz="1300">
+                <a:solidFill>
+                  <a:srgbClr val="FFFFFF"/>
+                </a:solidFill>
+              </a:defRPr>
+            </a:pPr>
+            <a:r>
+              <a:t>Nurtured by Doña Teodora</a:t>
+            </a:r>
+          </a:p>
+          <a:p>
+            <a:pPr>
+              <a:defRPr sz="1050">
+                <a:solidFill>
+                  <a:srgbClr val="F0F5FF"/>
+                </a:solidFill>
+              </a:defRPr>
+            </a:pPr>
+            <a:r>
+              <a:t>Rizal's mother served as his first teacher, instilling love for literature and moral courage through the Parable of the Moth.</a:t>
+            </a:r>
+          </a:p>
+        </p:txBody>
+      </p:sp>
+      <p:sp>
+        <p:nvSpPr>
+          <p:cNvPr id="6" name="!!Card_2"/>
+          <p:cNvSpPr/>
+          <p:nvPr/>
+        </p:nvSpPr>
+        <p:spPr>
+          <a:xfrm>
+            <a:off x="6126480" y="3108960"/>
+            <a:ext cx="5303520" cy="1280160"/>
+          </a:xfrm>
+          <a:prstGeom prst="roundRect">
+            <a:avLst/>
+          </a:prstGeom>
+          <a:solidFill>
+            <a:srgbClr val="193A62"/>
+          </a:solidFill>
+          <a:ln w="12700">
+            <a:solidFill>
+              <a:srgbClr val="F2B705"/>
+            </a:solidFill>
+          </a:ln>
+        </p:spPr>
+        <p:style>
+          <a:lnRef idx="1">
+            <a:schemeClr val="accent1"/>
+          </a:lnRef>
+          <a:fillRef idx="3">
+            <a:schemeClr val="accent1"/>
+          </a:fillRef>
+          <a:effectRef idx="2">
+            <a:schemeClr val="accent1"/>
+          </a:effectRef>
+          <a:fontRef idx="minor">
+            <a:schemeClr val="lt1"/>
+          </a:fontRef>
+        </p:style>
+        <p:txBody>
+          <a:bodyPr rtlCol="0" anchor="ctr" wrap="square"/>
+          <a:lstStyle/>
+          <a:p>
+            <a:pPr algn="ctr">
+              <a:defRPr b="1" sz="1300">
+                <a:solidFill>
+                  <a:srgbClr val="FFFFFF"/>
+                </a:solidFill>
+              </a:defRPr>
+            </a:pPr>
+            <a:r>
+              <a:t>Ancestral Agrarian Heritage</a:t>
+            </a:r>
+          </a:p>
+          <a:p>
+            <a:pPr>
+              <a:defRPr sz="1050">
+                <a:solidFill>
+                  <a:srgbClr val="F0F5FF"/>
+                </a:solidFill>
+              </a:defRPr>
+            </a:pPr>
+            <a:r>
+              <a:t>Growing up in prosperous Calamba exposed Rizal to agrarian disputes between tenant farmers and the Dominican hacienda.</a:t>
+            </a:r>
+          </a:p>
+        </p:txBody>
+      </p:sp>
+      <p:sp>
+        <p:nvSpPr>
+          <p:cNvPr id="7" name="!!Card_3"/>
+          <p:cNvSpPr/>
+          <p:nvPr/>
+        </p:nvSpPr>
+        <p:spPr>
+          <a:xfrm>
+            <a:off x="6126480" y="4572000"/>
+            <a:ext cx="5303520" cy="1280160"/>
+          </a:xfrm>
+          <a:prstGeom prst="roundRect">
+            <a:avLst/>
+          </a:prstGeom>
+          <a:solidFill>
+            <a:srgbClr val="193A62"/>
+          </a:solidFill>
+          <a:ln w="12700">
+            <a:solidFill>
+              <a:srgbClr val="F2B705"/>
+            </a:solidFill>
+          </a:ln>
+        </p:spPr>
+        <p:style>
+          <a:lnRef idx="1">
+            <a:schemeClr val="accent1"/>
+          </a:lnRef>
+          <a:fillRef idx="3">
+            <a:schemeClr val="accent1"/>
+          </a:fillRef>
+          <a:effectRef idx="2">
+            <a:schemeClr val="accent1"/>
+          </a:effectRef>
+          <a:fontRef idx="minor">
+            <a:schemeClr val="lt1"/>
+          </a:fontRef>
+        </p:style>
+        <p:txBody>
+          <a:bodyPr rtlCol="0" anchor="ctr" wrap="square"/>
+          <a:lstStyle/>
+          <a:p>
+            <a:pPr algn="ctr">
+              <a:defRPr b="1" sz="1300">
+                <a:solidFill>
+                  <a:srgbClr val="FFFFFF"/>
+                </a:solidFill>
+              </a:defRPr>
+            </a:pPr>
+            <a:r>
+              <a:t>The Martyrdom of GOMBURZA</a:t>
+            </a:r>
+          </a:p>
+          <a:p>
+            <a:pPr>
+              <a:defRPr sz="1050">
+                <a:solidFill>
+                  <a:srgbClr val="F0F5FF"/>
+                </a:solidFill>
+              </a:defRPr>
+            </a:pPr>
+            <a:r>
+              <a:t>The tragic 1872 execution of Fathers Gomez, Burgos, and Zamora profoundly awakened young Rizal's national consciousness.</a:t>
+            </a:r>
+          </a:p>
+        </p:txBody>
+      </p:sp>
+    </p:spTree>
+  </p:cSld>
+  <p:clrMapOvr>
+    <a:masterClrMapping/>
+  </p:clrMapOvr>
+  <mc:AlternateContent xmlns:mc="http://schemas.openxmlformats.org/markup-compatibility/2006">
+    <mc:Choice xmlns:p159="http://schemas.microsoft.com/office/powerpoint/2015/09/main" Requires="p159">
+      <p:transition spd="slow" p14:dur="1500">
+        <p159:morph option="byObject"/>
+      </p:transition>
+    </mc:Choice>
+    <mc:Fallback>
+      <p:transition spd="slow">
+        <p:fade/>
+      </p:transition>
+    </mc:Fallback>
+  </mc:AlternateContent>
+</p:sld>
+</file>
+
+<file path=ppt/slides/slide3.xml><?xml version="1.0" encoding="utf-8"?>
+<p:sld xmlns:p14="http://schemas.microsoft.com/office/powerpoint/2010/main" xmlns:a="http://schemas.openxmlformats.org/drawingml/2006/main" xmlns:p="http://schemas.openxmlformats.org/presentationml/2006/main" xmlns:r="http://schemas.openxmlformats.org/officeDocument/2006/relationships">
+  <p:cSld>
+    <p:spTree>
+      <p:nvGrpSpPr>
+        <p:cNvPr id="1" name=""/>
+        <p:cNvGrpSpPr/>
+        <p:nvPr/>
+      </p:nvGrpSpPr>
+      <p:grpSpPr/>
+      <p:sp>
+        <p:nvSpPr>
+          <p:cNvPr id="2" name="Rectangle 1"/>
+          <p:cNvSpPr/>
+          <p:nvPr/>
+        </p:nvSpPr>
+        <p:spPr>
+          <a:xfrm>
+            <a:off x="0" y="0"/>
+            <a:ext cx="12191695" cy="6858000"/>
+          </a:xfrm>
+          <a:prstGeom prst="rect">
+            <a:avLst/>
+          </a:prstGeom>
+          <a:solidFill>
+            <a:srgbClr val="0F2A4A"/>
+          </a:solidFill>
+          <a:ln>
+            <a:noFill/>
+          </a:ln>
+        </p:spPr>
+        <p:style>
+          <a:lnRef idx="1">
+            <a:schemeClr val="accent1"/>
+          </a:lnRef>
+          <a:fillRef idx="3">
+            <a:schemeClr val="accent1"/>
+          </a:fillRef>
+          <a:effectRef idx="2">
+            <a:schemeClr val="accent1"/>
+          </a:effectRef>
+          <a:fontRef idx="minor">
+            <a:schemeClr val="lt1"/>
+          </a:fontRef>
+        </p:style>
+        <p:txBody>
           <a:bodyPr rtlCol="0" anchor="ctr"/>
           <a:lstStyle/>
           <a:p>
@@ -5981,16 +5232,40 @@
           </a:p>
         </p:txBody>
       </p:sp>
-      <p:sp>
-        <p:nvSpPr>
-          <p:cNvPr id="7" name="TextBox 6"/>
+      <p:pic>
+        <p:nvPicPr>
+          <p:cNvPr id="3" name="!!Hero_Image" descr="rizal_education.png"/>
+          <p:cNvPicPr>
+            <a:picLocks noChangeAspect="1"/>
+          </p:cNvPicPr>
+          <p:nvPr/>
+        </p:nvPicPr>
+        <p:blipFill>
+          <a:blip r:embed="rId2"/>
+          <a:stretch>
+            <a:fillRect/>
+          </a:stretch>
+        </p:blipFill>
+        <p:spPr>
+          <a:xfrm>
+            <a:off x="731520" y="914400"/>
+            <a:ext cx="5029200" cy="5029200"/>
+          </a:xfrm>
+          <a:prstGeom prst="rect">
+            <a:avLst/>
+          </a:prstGeom>
+        </p:spPr>
+      </p:pic>
+      <p:sp>
+        <p:nvSpPr>
+          <p:cNvPr id="4" name="!!Title_Card"/>
           <p:cNvSpPr txBox="1"/>
           <p:nvPr/>
         </p:nvSpPr>
         <p:spPr>
           <a:xfrm>
-            <a:off x="1371600" y="2743200"/>
-            <a:ext cx="9448495" cy="2286000"/>
+            <a:off x="6217920" y="2011680"/>
+            <a:ext cx="5303520" cy="3200400"/>
           </a:xfrm>
           <a:prstGeom prst="rect">
             <a:avLst/>
@@ -6003,15 +5278,27 @@
           </a:bodyPr>
           <a:lstStyle/>
           <a:p>
-            <a:pPr algn="ctr">
-              <a:defRPr sz="3400" b="1">
+            <a:pPr>
+              <a:defRPr sz="3200" b="1">
+                <a:solidFill>
+                  <a:srgbClr val="FFFFFF"/>
+                </a:solidFill>
+              </a:defRPr>
+            </a:pPr>
+            <a:r>
+              <a:t>Scholastic Brilliance in Manila</a:t>
+            </a:r>
+          </a:p>
+          <a:p>
+            <a:pPr>
+              <a:defRPr sz="1600">
                 <a:solidFill>
                   <a:srgbClr val="F2B705"/>
                 </a:solidFill>
               </a:defRPr>
             </a:pPr>
             <a:r>
-              <a:t>"The pen is mightier than the sword when dipped in the ink of truth and human dignity."</a:t>
+              <a:t>Distinction at Ateneo Municipal &amp; Medical Studies at UST</a:t>
             </a:r>
           </a:p>
         </p:txBody>
@@ -6028,7 +5315,7 @@
 </file>
 
 <file path=ppt/slides/slide4.xml><?xml version="1.0" encoding="utf-8"?>
-<p:sld xmlns:a="http://schemas.openxmlformats.org/drawingml/2006/main" xmlns:p="http://schemas.openxmlformats.org/presentationml/2006/main" xmlns:r="http://schemas.openxmlformats.org/officeDocument/2006/relationships">
+<p:sld xmlns:p14="http://schemas.microsoft.com/office/powerpoint/2010/main" xmlns:a="http://schemas.openxmlformats.org/drawingml/2006/main" xmlns:p="http://schemas.openxmlformats.org/presentationml/2006/main" xmlns:r="http://schemas.openxmlformats.org/officeDocument/2006/relationships">
   <p:cSld>
     <p:spTree>
       <p:nvGrpSpPr>
@@ -6088,8 +5375,8 @@
         </p:nvSpPr>
         <p:spPr>
           <a:xfrm>
-            <a:off x="731520" y="6400800"/>
-            <a:ext cx="10728655" cy="320040"/>
+            <a:off x="731520" y="457200"/>
+            <a:ext cx="10698480" cy="1005840"/>
           </a:xfrm>
           <a:prstGeom prst="rect">
             <a:avLst/>
@@ -6097,43 +5384,81 @@
           <a:noFill/>
         </p:spPr>
         <p:txBody>
-          <a:bodyPr wrap="none">
+          <a:bodyPr wrap="square">
             <a:spAutoFit/>
           </a:bodyPr>
           <a:lstStyle/>
           <a:p>
             <a:pPr>
-              <a:defRPr sz="900">
-                <a:solidFill>
-                  <a:srgbClr val="93C5FD"/>
+              <a:defRPr sz="1100" b="1">
+                <a:solidFill>
+                  <a:srgbClr val="F2B705"/>
                 </a:solidFill>
               </a:defRPr>
             </a:pPr>
             <a:r>
-              <a:t>STI West Negros University  •  Jhon Paulo V. Gascon  •  Slide 4 of 11</a:t>
-            </a:r>
-          </a:p>
-        </p:txBody>
-      </p:sp>
-      <p:sp>
-        <p:nvSpPr>
-          <p:cNvPr id="4" name="Rectangle 3"/>
-          <p:cNvSpPr/>
+              <a:t>EXILE &amp; ADVOCACY</a:t>
+            </a:r>
+          </a:p>
+          <a:p>
+            <a:pPr>
+              <a:defRPr sz="2400" b="1">
+                <a:solidFill>
+                  <a:srgbClr val="FFFFFF"/>
+                </a:solidFill>
+              </a:defRPr>
+            </a:pPr>
+            <a:r>
+              <a:t>The Propaganda Movement in Europe</a:t>
+            </a:r>
+          </a:p>
+        </p:txBody>
+      </p:sp>
+      <p:pic>
+        <p:nvPicPr>
+          <p:cNvPr id="4" name="!!Content_Image" descr="rizal_europe.png"/>
+          <p:cNvPicPr>
+            <a:picLocks noChangeAspect="1"/>
+          </p:cNvPicPr>
           <p:nvPr/>
-        </p:nvSpPr>
-        <p:spPr>
-          <a:xfrm>
-            <a:off x="731520" y="2286000"/>
-            <a:ext cx="457200" cy="2560320"/>
+        </p:nvPicPr>
+        <p:blipFill>
+          <a:blip r:embed="rId2"/>
+          <a:stretch>
+            <a:fillRect/>
+          </a:stretch>
+        </p:blipFill>
+        <p:spPr>
+          <a:xfrm>
+            <a:off x="731520" y="1645920"/>
+            <a:ext cx="5029200" cy="4389120"/>
           </a:xfrm>
           <a:prstGeom prst="rect">
             <a:avLst/>
           </a:prstGeom>
+        </p:spPr>
+      </p:pic>
+      <p:sp>
+        <p:nvSpPr>
+          <p:cNvPr id="5" name="!!Card_1"/>
+          <p:cNvSpPr/>
+          <p:nvPr/>
+        </p:nvSpPr>
+        <p:spPr>
+          <a:xfrm>
+            <a:off x="6126480" y="1645920"/>
+            <a:ext cx="5303520" cy="1280160"/>
+          </a:xfrm>
+          <a:prstGeom prst="roundRect">
+            <a:avLst/>
+          </a:prstGeom>
           <a:solidFill>
-            <a:srgbClr val="F2B705"/>
+            <a:srgbClr val="193A62"/>
           </a:solidFill>
-          <a:ln>
-            <a:noFill/>
+          <a:ln w="12700">
+            <a:solidFill>
+              <a:srgbClr val="F2B705"/>
+            </a:solidFill>
           </a:ln>
         </p:spPr>
         <p:style>
@@ -6151,79 +5476,162 @@
           </a:fontRef>
         </p:style>
         <p:txBody>
-          <a:bodyPr rtlCol="0" anchor="ctr"/>
-          <a:lstStyle/>
-          <a:p>
-            <a:pPr algn="ctr"/>
-          </a:p>
-        </p:txBody>
-      </p:sp>
-      <p:sp>
-        <p:nvSpPr>
-          <p:cNvPr id="5" name="TextBox 4"/>
-          <p:cNvSpPr txBox="1"/>
+          <a:bodyPr rtlCol="0" anchor="ctr" wrap="square"/>
+          <a:lstStyle/>
+          <a:p>
+            <a:pPr algn="ctr">
+              <a:defRPr b="1" sz="1300">
+                <a:solidFill>
+                  <a:srgbClr val="FFFFFF"/>
+                </a:solidFill>
+              </a:defRPr>
+            </a:pPr>
+            <a:r>
+              <a:t>Writing for La Solidaridad</a:t>
+            </a:r>
+          </a:p>
+          <a:p>
+            <a:pPr>
+              <a:defRPr sz="1050">
+                <a:solidFill>
+                  <a:srgbClr val="F0F5FF"/>
+                </a:solidFill>
+              </a:defRPr>
+            </a:pPr>
+            <a:r>
+              <a:t>Together with Marcelo H. del Pilar and Graciano Lopez Jaena, Rizal campaigned for peaceful reforms and representation in the Spanish Cortes.</a:t>
+            </a:r>
+          </a:p>
+        </p:txBody>
+      </p:sp>
+      <p:sp>
+        <p:nvSpPr>
+          <p:cNvPr id="6" name="!!Card_2"/>
+          <p:cNvSpPr/>
           <p:nvPr/>
         </p:nvSpPr>
         <p:spPr>
           <a:xfrm>
-            <a:off x="1463040" y="2194560"/>
-            <a:ext cx="9601200" cy="1371600"/>
-          </a:xfrm>
-          <a:prstGeom prst="rect">
+            <a:off x="6126480" y="3108960"/>
+            <a:ext cx="5303520" cy="1280160"/>
+          </a:xfrm>
+          <a:prstGeom prst="roundRect">
             <a:avLst/>
           </a:prstGeom>
-          <a:noFill/>
-        </p:spPr>
-        <p:txBody>
-          <a:bodyPr wrap="none">
-            <a:spAutoFit/>
-          </a:bodyPr>
-          <a:lstStyle/>
+          <a:solidFill>
+            <a:srgbClr val="193A62"/>
+          </a:solidFill>
+          <a:ln w="12700">
+            <a:solidFill>
+              <a:srgbClr val="F2B705"/>
+            </a:solidFill>
+          </a:ln>
+        </p:spPr>
+        <p:style>
+          <a:lnRef idx="1">
+            <a:schemeClr val="accent1"/>
+          </a:lnRef>
+          <a:fillRef idx="3">
+            <a:schemeClr val="accent1"/>
+          </a:fillRef>
+          <a:effectRef idx="2">
+            <a:schemeClr val="accent1"/>
+          </a:effectRef>
+          <a:fontRef idx="minor">
+            <a:schemeClr val="lt1"/>
+          </a:fontRef>
+        </p:style>
+        <p:txBody>
+          <a:bodyPr rtlCol="0" anchor="ctr" wrap="square"/>
+          <a:lstStyle/>
+          <a:p>
+            <a:pPr algn="ctr">
+              <a:defRPr b="1" sz="1300">
+                <a:solidFill>
+                  <a:srgbClr val="FFFFFF"/>
+                </a:solidFill>
+              </a:defRPr>
+            </a:pPr>
+            <a:r>
+              <a:t>Annotations of Morga's Sucesos</a:t>
+            </a:r>
+          </a:p>
           <a:p>
             <a:pPr>
-              <a:defRPr sz="3800" b="1">
-                <a:solidFill>
-                  <a:srgbClr val="FFFFFF"/>
+              <a:defRPr sz="1050">
+                <a:solidFill>
+                  <a:srgbClr val="F0F5FF"/>
                 </a:solidFill>
               </a:defRPr>
             </a:pPr>
             <a:r>
-              <a:t>Part I: Awakening the National Conscience</a:t>
-            </a:r>
-          </a:p>
-        </p:txBody>
-      </p:sp>
-      <p:sp>
-        <p:nvSpPr>
-          <p:cNvPr id="6" name="TextBox 5"/>
-          <p:cNvSpPr txBox="1"/>
+              <a:t>Rizal painstakingly transcribed Antonio de Morga's 1609 work in London to prove that pre-colonial Filipinos possessed rich civilization.</a:t>
+            </a:r>
+          </a:p>
+        </p:txBody>
+      </p:sp>
+      <p:sp>
+        <p:nvSpPr>
+          <p:cNvPr id="7" name="!!Card_3"/>
+          <p:cNvSpPr/>
           <p:nvPr/>
         </p:nvSpPr>
         <p:spPr>
           <a:xfrm>
-            <a:off x="1463040" y="3657600"/>
-            <a:ext cx="9601200" cy="1371600"/>
-          </a:xfrm>
-          <a:prstGeom prst="rect">
+            <a:off x="6126480" y="4572000"/>
+            <a:ext cx="5303520" cy="1280160"/>
+          </a:xfrm>
+          <a:prstGeom prst="roundRect">
             <a:avLst/>
           </a:prstGeom>
-          <a:noFill/>
-        </p:spPr>
-        <p:txBody>
-          <a:bodyPr wrap="none">
-            <a:spAutoFit/>
-          </a:bodyPr>
-          <a:lstStyle/>
+          <a:solidFill>
+            <a:srgbClr val="193A62"/>
+          </a:solidFill>
+          <a:ln w="12700">
+            <a:solidFill>
+              <a:srgbClr val="F2B705"/>
+            </a:solidFill>
+          </a:ln>
+        </p:spPr>
+        <p:style>
+          <a:lnRef idx="1">
+            <a:schemeClr val="accent1"/>
+          </a:lnRef>
+          <a:fillRef idx="3">
+            <a:schemeClr val="accent1"/>
+          </a:fillRef>
+          <a:effectRef idx="2">
+            <a:schemeClr val="accent1"/>
+          </a:effectRef>
+          <a:fontRef idx="minor">
+            <a:schemeClr val="lt1"/>
+          </a:fontRef>
+        </p:style>
+        <p:txBody>
+          <a:bodyPr rtlCol="0" anchor="ctr" wrap="square"/>
+          <a:lstStyle/>
+          <a:p>
+            <a:pPr algn="ctr">
+              <a:defRPr b="1" sz="1300">
+                <a:solidFill>
+                  <a:srgbClr val="FFFFFF"/>
+                </a:solidFill>
+              </a:defRPr>
+            </a:pPr>
+            <a:r>
+              <a:t>Polymathic Pursuits</a:t>
+            </a:r>
+          </a:p>
           <a:p>
             <a:pPr>
-              <a:defRPr sz="2200">
-                <a:solidFill>
-                  <a:srgbClr val="93C5FD"/>
+              <a:defRPr sz="1050">
+                <a:solidFill>
+                  <a:srgbClr val="F0F5FF"/>
                 </a:solidFill>
               </a:defRPr>
             </a:pPr>
             <a:r>
-              <a:t>How literary realism exposed colonial abuses and ignited reform.</a:t>
+              <a:t>Mastered over 22 languages while specializing in ophthalmology under Dr. Louis de Wecker in Paris.</a:t>
             </a:r>
           </a:p>
         </p:txBody>
@@ -6233,14 +5641,23 @@
   <p:clrMapOvr>
     <a:masterClrMapping/>
   </p:clrMapOvr>
-  <p:transition spd="med">
-    <p:push dir="u"/>
-  </p:transition>
+  <mc:AlternateContent xmlns:mc="http://schemas.openxmlformats.org/markup-compatibility/2006">
+    <mc:Choice xmlns:p159="http://schemas.microsoft.com/office/powerpoint/2015/09/main" Requires="p159">
+      <p:transition spd="slow" p14:dur="1500">
+        <p159:morph option="byObject"/>
+      </p:transition>
+    </mc:Choice>
+    <mc:Fallback>
+      <p:transition spd="slow">
+        <p:fade/>
+      </p:transition>
+    </mc:Fallback>
+  </mc:AlternateContent>
 </p:sld>
 </file>
 
 <file path=ppt/slides/slide5.xml><?xml version="1.0" encoding="utf-8"?>
-<p:sld xmlns:a="http://schemas.openxmlformats.org/drawingml/2006/main" xmlns:p="http://schemas.openxmlformats.org/presentationml/2006/main" xmlns:r="http://schemas.openxmlformats.org/officeDocument/2006/relationships">
+<p:sld xmlns:p14="http://schemas.microsoft.com/office/powerpoint/2010/main" xmlns:a="http://schemas.openxmlformats.org/drawingml/2006/main" xmlns:p="http://schemas.openxmlformats.org/presentationml/2006/main" xmlns:r="http://schemas.openxmlformats.org/officeDocument/2006/relationships">
   <p:cSld>
     <p:spTree>
       <p:nvGrpSpPr>
@@ -6300,8 +5717,8 @@
         </p:nvSpPr>
         <p:spPr>
           <a:xfrm>
-            <a:off x="731520" y="365760"/>
-            <a:ext cx="10058400" cy="365760"/>
+            <a:off x="731520" y="457200"/>
+            <a:ext cx="10698480" cy="1005840"/>
           </a:xfrm>
           <a:prstGeom prst="rect">
             <a:avLst/>
@@ -6309,7 +5726,7 @@
           <a:noFill/>
         </p:spPr>
         <p:txBody>
-          <a:bodyPr wrap="none">
+          <a:bodyPr wrap="square">
             <a:spAutoFit/>
           </a:bodyPr>
           <a:lstStyle/>
@@ -6322,97 +5739,39 @@
               </a:defRPr>
             </a:pPr>
             <a:r>
-              <a:t>EMPIRICAL EVIDENCE &amp; TRENDS</a:t>
-            </a:r>
-          </a:p>
-        </p:txBody>
-      </p:sp>
-      <p:sp>
-        <p:nvSpPr>
-          <p:cNvPr id="4" name="TextBox 3"/>
-          <p:cNvSpPr txBox="1"/>
-          <p:nvPr/>
-        </p:nvSpPr>
-        <p:spPr>
-          <a:xfrm>
-            <a:off x="731520" y="685800"/>
-            <a:ext cx="10515600" cy="731520"/>
-          </a:xfrm>
-          <a:prstGeom prst="rect">
-            <a:avLst/>
-          </a:prstGeom>
-          <a:noFill/>
-        </p:spPr>
-        <p:txBody>
-          <a:bodyPr wrap="none">
-            <a:spAutoFit/>
-          </a:bodyPr>
-          <a:lstStyle/>
+              <a:t>REFORM OBJECTIVES</a:t>
+            </a:r>
+          </a:p>
           <a:p>
             <a:pPr>
-              <a:defRPr sz="2600" b="1">
+              <a:defRPr sz="2400" b="1">
                 <a:solidFill>
                   <a:srgbClr val="FFFFFF"/>
                 </a:solidFill>
               </a:defRPr>
             </a:pPr>
             <a:r>
-              <a:t>Rizal's Prolific Intellectual Footprint</a:t>
-            </a:r>
-          </a:p>
-        </p:txBody>
-      </p:sp>
-      <p:sp>
-        <p:nvSpPr>
-          <p:cNvPr id="5" name="TextBox 4"/>
-          <p:cNvSpPr txBox="1"/>
-          <p:nvPr/>
-        </p:nvSpPr>
-        <p:spPr>
-          <a:xfrm>
-            <a:off x="731520" y="6400800"/>
-            <a:ext cx="10728655" cy="320040"/>
-          </a:xfrm>
-          <a:prstGeom prst="rect">
-            <a:avLst/>
-          </a:prstGeom>
-          <a:noFill/>
-        </p:spPr>
-        <p:txBody>
-          <a:bodyPr wrap="none">
-            <a:spAutoFit/>
-          </a:bodyPr>
-          <a:lstStyle/>
-          <a:p>
-            <a:pPr>
-              <a:defRPr sz="900">
-                <a:solidFill>
-                  <a:srgbClr val="93C5FD"/>
-                </a:solidFill>
-              </a:defRPr>
-            </a:pPr>
-            <a:r>
-              <a:t>STI West Negros University  •  Jhon Paulo V. Gascon  •  Slide 5 of 11</a:t>
-            </a:r>
-          </a:p>
-        </p:txBody>
-      </p:sp>
-      <p:sp>
-        <p:nvSpPr>
-          <p:cNvPr id="6" name="Rounded Rectangle 5"/>
+              <a:t>Three Foundations of the Propaganda Movement</a:t>
+            </a:r>
+          </a:p>
+        </p:txBody>
+      </p:sp>
+      <p:sp>
+        <p:nvSpPr>
+          <p:cNvPr id="4" name="!!Card_1"/>
           <p:cNvSpPr/>
           <p:nvPr/>
         </p:nvSpPr>
         <p:spPr>
           <a:xfrm>
-            <a:off x="731520" y="2011680"/>
-            <a:ext cx="3413455" cy="3840480"/>
+            <a:off x="731520" y="1645920"/>
+            <a:ext cx="3291840" cy="4114800"/>
           </a:xfrm>
           <a:prstGeom prst="roundRect">
             <a:avLst/>
           </a:prstGeom>
           <a:solidFill>
-            <a:srgbClr val="183B64"/>
+            <a:srgbClr val="193A62"/>
           </a:solidFill>
           <a:ln w="19050">
             <a:solidFill>
@@ -6435,79 +5794,50 @@
           </a:fontRef>
         </p:style>
         <p:txBody>
-          <a:bodyPr rtlCol="0" anchor="ctr"/>
-          <a:lstStyle/>
-          <a:p>
-            <a:pPr algn="ctr"/>
-          </a:p>
-        </p:txBody>
-      </p:sp>
-      <p:sp>
-        <p:nvSpPr>
-          <p:cNvPr id="7" name="TextBox 6"/>
-          <p:cNvSpPr txBox="1"/>
-          <p:nvPr/>
-        </p:nvSpPr>
-        <p:spPr>
-          <a:xfrm>
-            <a:off x="914400" y="2286000"/>
-            <a:ext cx="3047695" cy="3200400"/>
-          </a:xfrm>
-          <a:prstGeom prst="rect">
-            <a:avLst/>
-          </a:prstGeom>
-          <a:noFill/>
-        </p:spPr>
-        <p:txBody>
-          <a:bodyPr wrap="square">
-            <a:spAutoFit/>
-          </a:bodyPr>
-          <a:lstStyle/>
+          <a:bodyPr rtlCol="0" anchor="ctr" wrap="square"/>
+          <a:lstStyle/>
+          <a:p>
+            <a:pPr algn="ctr">
+              <a:defRPr b="1" sz="1500">
+                <a:solidFill>
+                  <a:srgbClr val="F2B705"/>
+                </a:solidFill>
+              </a:defRPr>
+            </a:pPr>
+            <a:r>
+              <a:t>1. Equality Before the Law</a:t>
+            </a:r>
+          </a:p>
           <a:p>
             <a:pPr>
-              <a:defRPr sz="4800" b="1">
-                <a:solidFill>
-                  <a:srgbClr val="F2B705"/>
+              <a:defRPr sz="1100">
+                <a:solidFill>
+                  <a:srgbClr val="F0F0F0"/>
                 </a:solidFill>
               </a:defRPr>
             </a:pPr>
             <a:r>
-              <a:t>22+</a:t>
-            </a:r>
-          </a:p>
-          <a:p>
-            <a:pPr>
-              <a:spcBef>
-                <a:spcPts val="1600"/>
-              </a:spcBef>
-              <a:defRPr sz="1600">
-                <a:solidFill>
-                  <a:srgbClr val="FFFFFF"/>
-                </a:solidFill>
-              </a:defRPr>
-            </a:pPr>
-            <a:r>
-              <a:t>Languages mastered across Asia, Europe, and America</a:t>
-            </a:r>
-          </a:p>
-        </p:txBody>
-      </p:sp>
-      <p:sp>
-        <p:nvSpPr>
-          <p:cNvPr id="8" name="Rounded Rectangle 7"/>
+              <a:t>Demanding that native Filipinos enjoy identical civil liberties, legal protections, and due process as peninsulares.</a:t>
+            </a:r>
+          </a:p>
+        </p:txBody>
+      </p:sp>
+      <p:sp>
+        <p:nvSpPr>
+          <p:cNvPr id="5" name="!!Card_2"/>
           <p:cNvSpPr/>
           <p:nvPr/>
         </p:nvSpPr>
         <p:spPr>
           <a:xfrm>
-            <a:off x="4389120" y="2011680"/>
-            <a:ext cx="3413455" cy="3840480"/>
+            <a:off x="4389120" y="1645920"/>
+            <a:ext cx="3291840" cy="4114800"/>
           </a:xfrm>
           <a:prstGeom prst="roundRect">
             <a:avLst/>
           </a:prstGeom>
           <a:solidFill>
-            <a:srgbClr val="183B64"/>
+            <a:srgbClr val="193A62"/>
           </a:solidFill>
           <a:ln w="19050">
             <a:solidFill>
@@ -6530,79 +5860,50 @@
           </a:fontRef>
         </p:style>
         <p:txBody>
-          <a:bodyPr rtlCol="0" anchor="ctr"/>
-          <a:lstStyle/>
-          <a:p>
-            <a:pPr algn="ctr"/>
-          </a:p>
-        </p:txBody>
-      </p:sp>
-      <p:sp>
-        <p:nvSpPr>
-          <p:cNvPr id="9" name="TextBox 8"/>
-          <p:cNvSpPr txBox="1"/>
-          <p:nvPr/>
-        </p:nvSpPr>
-        <p:spPr>
-          <a:xfrm>
-            <a:off x="4572000" y="2286000"/>
-            <a:ext cx="3047695" cy="3200400"/>
-          </a:xfrm>
-          <a:prstGeom prst="rect">
-            <a:avLst/>
-          </a:prstGeom>
-          <a:noFill/>
-        </p:spPr>
-        <p:txBody>
-          <a:bodyPr wrap="square">
-            <a:spAutoFit/>
-          </a:bodyPr>
-          <a:lstStyle/>
+          <a:bodyPr rtlCol="0" anchor="ctr" wrap="square"/>
+          <a:lstStyle/>
+          <a:p>
+            <a:pPr algn="ctr">
+              <a:defRPr b="1" sz="1500">
+                <a:solidFill>
+                  <a:srgbClr val="F2B705"/>
+                </a:solidFill>
+              </a:defRPr>
+            </a:pPr>
+            <a:r>
+              <a:t>2. Representation in Cortes</a:t>
+            </a:r>
+          </a:p>
           <a:p>
             <a:pPr>
-              <a:defRPr sz="4800" b="1">
-                <a:solidFill>
-                  <a:srgbClr val="F2B705"/>
+              <a:defRPr sz="1100">
+                <a:solidFill>
+                  <a:srgbClr val="F0F0F0"/>
                 </a:solidFill>
               </a:defRPr>
             </a:pPr>
             <a:r>
-              <a:t>2</a:t>
-            </a:r>
-          </a:p>
-          <a:p>
-            <a:pPr>
-              <a:spcBef>
-                <a:spcPts val="1600"/>
-              </a:spcBef>
-              <a:defRPr sz="1600">
-                <a:solidFill>
-                  <a:srgbClr val="FFFFFF"/>
-                </a:solidFill>
-              </a:defRPr>
-            </a:pPr>
-            <a:r>
-              <a:t>Epochal novels that dismantled Spanish colonial hegemony</a:t>
-            </a:r>
-          </a:p>
-        </p:txBody>
-      </p:sp>
-      <p:sp>
-        <p:nvSpPr>
-          <p:cNvPr id="10" name="Rounded Rectangle 9"/>
+              <a:t>Securing parliamentary representation in Madrid to articulate Philippine economic and social grievances.</a:t>
+            </a:r>
+          </a:p>
+        </p:txBody>
+      </p:sp>
+      <p:sp>
+        <p:nvSpPr>
+          <p:cNvPr id="6" name="!!Card_3"/>
           <p:cNvSpPr/>
           <p:nvPr/>
         </p:nvSpPr>
         <p:spPr>
           <a:xfrm>
-            <a:off x="8046720" y="2011680"/>
-            <a:ext cx="3413455" cy="3840480"/>
+            <a:off x="8046720" y="1645920"/>
+            <a:ext cx="3291840" cy="4114800"/>
           </a:xfrm>
           <a:prstGeom prst="roundRect">
             <a:avLst/>
           </a:prstGeom>
           <a:solidFill>
-            <a:srgbClr val="183B64"/>
+            <a:srgbClr val="193A62"/>
           </a:solidFill>
           <a:ln w="19050">
             <a:solidFill>
@@ -6625,59 +5926,30 @@
           </a:fontRef>
         </p:style>
         <p:txBody>
-          <a:bodyPr rtlCol="0" anchor="ctr"/>
-          <a:lstStyle/>
-          <a:p>
-            <a:pPr algn="ctr"/>
-          </a:p>
-        </p:txBody>
-      </p:sp>
-      <p:sp>
-        <p:nvSpPr>
-          <p:cNvPr id="11" name="TextBox 10"/>
-          <p:cNvSpPr txBox="1"/>
-          <p:nvPr/>
-        </p:nvSpPr>
-        <p:spPr>
-          <a:xfrm>
-            <a:off x="8229600" y="2286000"/>
-            <a:ext cx="3047695" cy="3200400"/>
-          </a:xfrm>
-          <a:prstGeom prst="rect">
-            <a:avLst/>
-          </a:prstGeom>
-          <a:noFill/>
-        </p:spPr>
-        <p:txBody>
-          <a:bodyPr wrap="square">
-            <a:spAutoFit/>
-          </a:bodyPr>
-          <a:lstStyle/>
+          <a:bodyPr rtlCol="0" anchor="ctr" wrap="square"/>
+          <a:lstStyle/>
+          <a:p>
+            <a:pPr algn="ctr">
+              <a:defRPr b="1" sz="1500">
+                <a:solidFill>
+                  <a:srgbClr val="F2B705"/>
+                </a:solidFill>
+              </a:defRPr>
+            </a:pPr>
+            <a:r>
+              <a:t>3. Secularization of Parishes</a:t>
+            </a:r>
+          </a:p>
           <a:p>
             <a:pPr>
-              <a:defRPr sz="4800" b="1">
-                <a:solidFill>
-                  <a:srgbClr val="F2B705"/>
+              <a:defRPr sz="1100">
+                <a:solidFill>
+                  <a:srgbClr val="F0F0F0"/>
                 </a:solidFill>
               </a:defRPr>
             </a:pPr>
             <a:r>
-              <a:t>35</a:t>
-            </a:r>
-          </a:p>
-          <a:p>
-            <a:pPr>
-              <a:spcBef>
-                <a:spcPts val="1600"/>
-              </a:spcBef>
-              <a:defRPr sz="1600">
-                <a:solidFill>
-                  <a:srgbClr val="FFFFFF"/>
-                </a:solidFill>
-              </a:defRPr>
-            </a:pPr>
-            <a:r>
-              <a:t>Years of life dedicated entirely to patriotic enlightenment</a:t>
+              <a:t>Ending monastic abuse and transferring parish administration to qualified Filipino secular priests.</a:t>
             </a:r>
           </a:p>
         </p:txBody>
@@ -6694,7 +5966,7 @@
 </file>
 
 <file path=ppt/slides/slide6.xml><?xml version="1.0" encoding="utf-8"?>
-<p:sld xmlns:a="http://schemas.openxmlformats.org/drawingml/2006/main" xmlns:p="http://schemas.openxmlformats.org/presentationml/2006/main" xmlns:r="http://schemas.openxmlformats.org/officeDocument/2006/relationships">
+<p:sld xmlns:p14="http://schemas.microsoft.com/office/powerpoint/2010/main" xmlns:a="http://schemas.openxmlformats.org/drawingml/2006/main" xmlns:p="http://schemas.openxmlformats.org/presentationml/2006/main" xmlns:r="http://schemas.openxmlformats.org/officeDocument/2006/relationships">
   <p:cSld>
     <p:spTree>
       <p:nvGrpSpPr>
@@ -6754,8 +6026,8 @@
         </p:nvSpPr>
         <p:spPr>
           <a:xfrm>
-            <a:off x="731520" y="365760"/>
-            <a:ext cx="10058400" cy="365760"/>
+            <a:off x="731520" y="457200"/>
+            <a:ext cx="10698480" cy="1005840"/>
           </a:xfrm>
           <a:prstGeom prst="rect">
             <a:avLst/>
@@ -6763,7 +6035,7 @@
           <a:noFill/>
         </p:spPr>
         <p:txBody>
-          <a:bodyPr wrap="none">
+          <a:bodyPr wrap="square">
             <a:spAutoFit/>
           </a:bodyPr>
           <a:lstStyle/>
@@ -6776,101 +6048,67 @@
               </a:defRPr>
             </a:pPr>
             <a:r>
-              <a:t>STRATEGIC FRAMEWORK</a:t>
-            </a:r>
-          </a:p>
-        </p:txBody>
-      </p:sp>
-      <p:sp>
-        <p:nvSpPr>
-          <p:cNvPr id="4" name="TextBox 3"/>
-          <p:cNvSpPr txBox="1"/>
+              <a:t>LITERARY MASTERPIECE</a:t>
+            </a:r>
+          </a:p>
+          <a:p>
+            <a:pPr>
+              <a:defRPr sz="2400" b="1">
+                <a:solidFill>
+                  <a:srgbClr val="FFFFFF"/>
+                </a:solidFill>
+              </a:defRPr>
+            </a:pPr>
+            <a:r>
+              <a:t>Noli Me Tangere: The Social Cancer</a:t>
+            </a:r>
+          </a:p>
+        </p:txBody>
+      </p:sp>
+      <p:pic>
+        <p:nvPicPr>
+          <p:cNvPr id="4" name="!!Content_Image" descr="rizal_noli.png"/>
+          <p:cNvPicPr>
+            <a:picLocks noChangeAspect="1"/>
+          </p:cNvPicPr>
           <p:nvPr/>
-        </p:nvSpPr>
-        <p:spPr>
-          <a:xfrm>
-            <a:off x="731520" y="685800"/>
-            <a:ext cx="10515600" cy="731520"/>
+        </p:nvPicPr>
+        <p:blipFill>
+          <a:blip r:embed="rId2"/>
+          <a:stretch>
+            <a:fillRect/>
+          </a:stretch>
+        </p:blipFill>
+        <p:spPr>
+          <a:xfrm>
+            <a:off x="731520" y="1645920"/>
+            <a:ext cx="5029200" cy="4389120"/>
           </a:xfrm>
           <a:prstGeom prst="rect">
             <a:avLst/>
           </a:prstGeom>
-          <a:noFill/>
-        </p:spPr>
-        <p:txBody>
-          <a:bodyPr wrap="none">
-            <a:spAutoFit/>
-          </a:bodyPr>
-          <a:lstStyle/>
-          <a:p>
-            <a:pPr>
-              <a:defRPr sz="2600" b="1">
-                <a:solidFill>
-                  <a:srgbClr val="FFFFFF"/>
-                </a:solidFill>
-              </a:defRPr>
-            </a:pPr>
-            <a:r>
-              <a:t>Three Pillars of Rizal's Reformist Philosophy</a:t>
-            </a:r>
-          </a:p>
-        </p:txBody>
-      </p:sp>
-      <p:sp>
-        <p:nvSpPr>
-          <p:cNvPr id="5" name="TextBox 4"/>
-          <p:cNvSpPr txBox="1"/>
-          <p:nvPr/>
-        </p:nvSpPr>
-        <p:spPr>
-          <a:xfrm>
-            <a:off x="731520" y="6400800"/>
-            <a:ext cx="10728655" cy="320040"/>
-          </a:xfrm>
-          <a:prstGeom prst="rect">
-            <a:avLst/>
-          </a:prstGeom>
-          <a:noFill/>
-        </p:spPr>
-        <p:txBody>
-          <a:bodyPr wrap="none">
-            <a:spAutoFit/>
-          </a:bodyPr>
-          <a:lstStyle/>
-          <a:p>
-            <a:pPr>
-              <a:defRPr sz="900">
-                <a:solidFill>
-                  <a:srgbClr val="93C5FD"/>
-                </a:solidFill>
-              </a:defRPr>
-            </a:pPr>
-            <a:r>
-              <a:t>STI West Negros University  •  Jhon Paulo V. Gascon  •  Slide 6 of 11</a:t>
-            </a:r>
-          </a:p>
-        </p:txBody>
-      </p:sp>
-      <p:sp>
-        <p:nvSpPr>
-          <p:cNvPr id="6" name="Rounded Rectangle 5"/>
+        </p:spPr>
+      </p:pic>
+      <p:sp>
+        <p:nvSpPr>
+          <p:cNvPr id="5" name="!!Card_1"/>
           <p:cNvSpPr/>
           <p:nvPr/>
         </p:nvSpPr>
         <p:spPr>
           <a:xfrm>
-            <a:off x="731520" y="2011680"/>
-            <a:ext cx="3413455" cy="3840480"/>
+            <a:off x="6126480" y="1645920"/>
+            <a:ext cx="5303520" cy="1280160"/>
           </a:xfrm>
           <a:prstGeom prst="roundRect">
             <a:avLst/>
           </a:prstGeom>
           <a:solidFill>
-            <a:srgbClr val="183B64"/>
+            <a:srgbClr val="193A62"/>
           </a:solidFill>
-          <a:ln w="19050">
+          <a:ln w="12700">
             <a:solidFill>
-              <a:srgbClr val="3E7CB1"/>
+              <a:srgbClr val="F2B705"/>
             </a:solidFill>
           </a:ln>
         </p:spPr>
@@ -6889,83 +6127,54 @@
           </a:fontRef>
         </p:style>
         <p:txBody>
-          <a:bodyPr rtlCol="0" anchor="ctr"/>
-          <a:lstStyle/>
-          <a:p>
-            <a:pPr algn="ctr"/>
-          </a:p>
-        </p:txBody>
-      </p:sp>
-      <p:sp>
-        <p:nvSpPr>
-          <p:cNvPr id="7" name="TextBox 6"/>
-          <p:cNvSpPr txBox="1"/>
-          <p:nvPr/>
-        </p:nvSpPr>
-        <p:spPr>
-          <a:xfrm>
-            <a:off x="914400" y="2286000"/>
-            <a:ext cx="3047695" cy="3200400"/>
-          </a:xfrm>
-          <a:prstGeom prst="rect">
-            <a:avLst/>
-          </a:prstGeom>
-          <a:noFill/>
-        </p:spPr>
-        <p:txBody>
-          <a:bodyPr wrap="square">
-            <a:spAutoFit/>
-          </a:bodyPr>
-          <a:lstStyle/>
+          <a:bodyPr rtlCol="0" anchor="ctr" wrap="square"/>
+          <a:lstStyle/>
+          <a:p>
+            <a:pPr algn="ctr">
+              <a:defRPr b="1" sz="1300">
+                <a:solidFill>
+                  <a:srgbClr val="FFFFFF"/>
+                </a:solidFill>
+              </a:defRPr>
+            </a:pPr>
+            <a:r>
+              <a:t>Published in Berlin (1887)</a:t>
+            </a:r>
+          </a:p>
           <a:p>
             <a:pPr>
-              <a:defRPr sz="2000" b="1">
-                <a:solidFill>
-                  <a:srgbClr val="F2B705"/>
+              <a:defRPr sz="1050">
+                <a:solidFill>
+                  <a:srgbClr val="F0F5FF"/>
                 </a:solidFill>
               </a:defRPr>
             </a:pPr>
             <a:r>
-              <a:t>Universal Education</a:t>
-            </a:r>
-          </a:p>
-          <a:p>
-            <a:pPr>
-              <a:spcBef>
-                <a:spcPts val="1400"/>
-              </a:spcBef>
-              <a:defRPr sz="1400">
-                <a:solidFill>
-                  <a:srgbClr val="FFFFFF"/>
-                </a:solidFill>
-              </a:defRPr>
-            </a:pPr>
-            <a:r>
-              <a:t>The non-negotiable prerequisite for national emancipation and self-governance.</a:t>
-            </a:r>
-          </a:p>
-        </p:txBody>
-      </p:sp>
-      <p:sp>
-        <p:nvSpPr>
-          <p:cNvPr id="8" name="Rounded Rectangle 7"/>
+              <a:t>Funded through the crucial financial assistance of his dear friend Dr. Maximo Viola.</a:t>
+            </a:r>
+          </a:p>
+        </p:txBody>
+      </p:sp>
+      <p:sp>
+        <p:nvSpPr>
+          <p:cNvPr id="6" name="!!Card_2"/>
           <p:cNvSpPr/>
           <p:nvPr/>
         </p:nvSpPr>
         <p:spPr>
           <a:xfrm>
-            <a:off x="4389120" y="2011680"/>
-            <a:ext cx="3413455" cy="3840480"/>
+            <a:off x="6126480" y="3108960"/>
+            <a:ext cx="5303520" cy="1280160"/>
           </a:xfrm>
           <a:prstGeom prst="roundRect">
             <a:avLst/>
           </a:prstGeom>
           <a:solidFill>
-            <a:srgbClr val="183B64"/>
+            <a:srgbClr val="193A62"/>
           </a:solidFill>
-          <a:ln w="19050">
+          <a:ln w="12700">
             <a:solidFill>
-              <a:srgbClr val="3E7CB1"/>
+              <a:srgbClr val="F2B705"/>
             </a:solidFill>
           </a:ln>
         </p:spPr>
@@ -6984,83 +6193,54 @@
           </a:fontRef>
         </p:style>
         <p:txBody>
-          <a:bodyPr rtlCol="0" anchor="ctr"/>
-          <a:lstStyle/>
-          <a:p>
-            <a:pPr algn="ctr"/>
-          </a:p>
-        </p:txBody>
-      </p:sp>
-      <p:sp>
-        <p:nvSpPr>
-          <p:cNvPr id="9" name="TextBox 8"/>
-          <p:cNvSpPr txBox="1"/>
-          <p:nvPr/>
-        </p:nvSpPr>
-        <p:spPr>
-          <a:xfrm>
-            <a:off x="4572000" y="2286000"/>
-            <a:ext cx="3047695" cy="3200400"/>
-          </a:xfrm>
-          <a:prstGeom prst="rect">
-            <a:avLst/>
-          </a:prstGeom>
-          <a:noFill/>
-        </p:spPr>
-        <p:txBody>
-          <a:bodyPr wrap="square">
-            <a:spAutoFit/>
-          </a:bodyPr>
-          <a:lstStyle/>
+          <a:bodyPr rtlCol="0" anchor="ctr" wrap="square"/>
+          <a:lstStyle/>
+          <a:p>
+            <a:pPr algn="ctr">
+              <a:defRPr b="1" sz="1300">
+                <a:solidFill>
+                  <a:srgbClr val="FFFFFF"/>
+                </a:solidFill>
+              </a:defRPr>
+            </a:pPr>
+            <a:r>
+              <a:t>Diagnosing Colonial Affliction</a:t>
+            </a:r>
+          </a:p>
           <a:p>
             <a:pPr>
-              <a:defRPr sz="2000" b="1">
-                <a:solidFill>
-                  <a:srgbClr val="F2B705"/>
+              <a:defRPr sz="1050">
+                <a:solidFill>
+                  <a:srgbClr val="F0F5FF"/>
                 </a:solidFill>
               </a:defRPr>
             </a:pPr>
             <a:r>
-              <a:t>Civic Responsibility</a:t>
-            </a:r>
-          </a:p>
-          <a:p>
-            <a:pPr>
-              <a:spcBef>
-                <a:spcPts val="1400"/>
-              </a:spcBef>
-              <a:defRPr sz="1400">
-                <a:solidFill>
-                  <a:srgbClr val="FFFFFF"/>
-                </a:solidFill>
-              </a:defRPr>
-            </a:pPr>
-            <a:r>
-              <a:t>Active moral rectitude, economic cooperative industry, and self-reliance.</a:t>
-            </a:r>
-          </a:p>
-        </p:txBody>
-      </p:sp>
-      <p:sp>
-        <p:nvSpPr>
-          <p:cNvPr id="10" name="Rounded Rectangle 9"/>
+              <a:t>Through characters like Crisostomo Ibarra, Maria Clara, and Padre Damaso, Rizal unmasked clerical abuse and colonial hypocrisy.</a:t>
+            </a:r>
+          </a:p>
+        </p:txBody>
+      </p:sp>
+      <p:sp>
+        <p:nvSpPr>
+          <p:cNvPr id="7" name="!!Card_3"/>
           <p:cNvSpPr/>
           <p:nvPr/>
         </p:nvSpPr>
         <p:spPr>
           <a:xfrm>
-            <a:off x="8046720" y="2011680"/>
-            <a:ext cx="3413455" cy="3840480"/>
+            <a:off x="6126480" y="4572000"/>
+            <a:ext cx="5303520" cy="1280160"/>
           </a:xfrm>
           <a:prstGeom prst="roundRect">
             <a:avLst/>
           </a:prstGeom>
           <a:solidFill>
-            <a:srgbClr val="183B64"/>
+            <a:srgbClr val="193A62"/>
           </a:solidFill>
-          <a:ln w="19050">
+          <a:ln w="12700">
             <a:solidFill>
-              <a:srgbClr val="3E7CB1"/>
+              <a:srgbClr val="F2B705"/>
             </a:solidFill>
           </a:ln>
         </p:spPr>
@@ -7079,59 +6259,30 @@
           </a:fontRef>
         </p:style>
         <p:txBody>
-          <a:bodyPr rtlCol="0" anchor="ctr"/>
-          <a:lstStyle/>
-          <a:p>
-            <a:pPr algn="ctr"/>
-          </a:p>
-        </p:txBody>
-      </p:sp>
-      <p:sp>
-        <p:nvSpPr>
-          <p:cNvPr id="11" name="TextBox 10"/>
-          <p:cNvSpPr txBox="1"/>
-          <p:nvPr/>
-        </p:nvSpPr>
-        <p:spPr>
-          <a:xfrm>
-            <a:off x="8229600" y="2286000"/>
-            <a:ext cx="3047695" cy="3200400"/>
-          </a:xfrm>
-          <a:prstGeom prst="rect">
-            <a:avLst/>
-          </a:prstGeom>
-          <a:noFill/>
-        </p:spPr>
-        <p:txBody>
-          <a:bodyPr wrap="square">
-            <a:spAutoFit/>
-          </a:bodyPr>
-          <a:lstStyle/>
+          <a:bodyPr rtlCol="0" anchor="ctr" wrap="square"/>
+          <a:lstStyle/>
+          <a:p>
+            <a:pPr algn="ctr">
+              <a:defRPr b="1" sz="1300">
+                <a:solidFill>
+                  <a:srgbClr val="FFFFFF"/>
+                </a:solidFill>
+              </a:defRPr>
+            </a:pPr>
+            <a:r>
+              <a:t>The Awakening of Elias</a:t>
+            </a:r>
+          </a:p>
           <a:p>
             <a:pPr>
-              <a:defRPr sz="2000" b="1">
-                <a:solidFill>
-                  <a:srgbClr val="F2B705"/>
+              <a:defRPr sz="1050">
+                <a:solidFill>
+                  <a:srgbClr val="F0F5FF"/>
                 </a:solidFill>
               </a:defRPr>
             </a:pPr>
             <a:r>
-              <a:t>Critical Consciousness</a:t>
-            </a:r>
-          </a:p>
-          <a:p>
-            <a:pPr>
-              <a:spcBef>
-                <a:spcPts val="1400"/>
-              </a:spcBef>
-              <a:defRPr sz="1400">
-                <a:solidFill>
-                  <a:srgbClr val="FFFFFF"/>
-                </a:solidFill>
-              </a:defRPr>
-            </a:pPr>
-            <a:r>
-              <a:t>Refusal to accept superstition, tyranny, or subservience as natural conditions.</a:t>
+              <a:t>Introduced the voice of the oppressed masses who demanded radical liberation from systemic tyranny.</a:t>
             </a:r>
           </a:p>
         </p:txBody>
@@ -7148,7 +6299,7 @@
 </file>
 
 <file path=ppt/slides/slide7.xml><?xml version="1.0" encoding="utf-8"?>
-<p:sld xmlns:a="http://schemas.openxmlformats.org/drawingml/2006/main" xmlns:p="http://schemas.openxmlformats.org/presentationml/2006/main" xmlns:r="http://schemas.openxmlformats.org/officeDocument/2006/relationships">
+<p:sld xmlns:p14="http://schemas.microsoft.com/office/powerpoint/2010/main" xmlns:a="http://schemas.openxmlformats.org/drawingml/2006/main" xmlns:p="http://schemas.openxmlformats.org/presentationml/2006/main" xmlns:r="http://schemas.openxmlformats.org/officeDocument/2006/relationships">
   <p:cSld>
     <p:spTree>
       <p:nvGrpSpPr>
@@ -7200,16 +6351,40 @@
           </a:p>
         </p:txBody>
       </p:sp>
-      <p:sp>
-        <p:nvSpPr>
-          <p:cNvPr id="3" name="TextBox 2"/>
+      <p:pic>
+        <p:nvPicPr>
+          <p:cNvPr id="3" name="!!Hero_Image" descr="rizal_fili.png"/>
+          <p:cNvPicPr>
+            <a:picLocks noChangeAspect="1"/>
+          </p:cNvPicPr>
+          <p:nvPr/>
+        </p:nvPicPr>
+        <p:blipFill>
+          <a:blip r:embed="rId2"/>
+          <a:stretch>
+            <a:fillRect/>
+          </a:stretch>
+        </p:blipFill>
+        <p:spPr>
+          <a:xfrm>
+            <a:off x="731520" y="914400"/>
+            <a:ext cx="5029200" cy="5029200"/>
+          </a:xfrm>
+          <a:prstGeom prst="rect">
+            <a:avLst/>
+          </a:prstGeom>
+        </p:spPr>
+      </p:pic>
+      <p:sp>
+        <p:nvSpPr>
+          <p:cNvPr id="4" name="!!Title_Card"/>
           <p:cNvSpPr txBox="1"/>
           <p:nvPr/>
         </p:nvSpPr>
         <p:spPr>
           <a:xfrm>
-            <a:off x="731520" y="365760"/>
-            <a:ext cx="10058400" cy="365760"/>
+            <a:off x="6217920" y="2011680"/>
+            <a:ext cx="5303520" cy="3200400"/>
           </a:xfrm>
           <a:prstGeom prst="rect">
             <a:avLst/>
@@ -7217,115 +6392,85 @@
           <a:noFill/>
         </p:spPr>
         <p:txBody>
-          <a:bodyPr wrap="none">
+          <a:bodyPr wrap="square">
             <a:spAutoFit/>
           </a:bodyPr>
           <a:lstStyle/>
           <a:p>
             <a:pPr>
-              <a:defRPr sz="1100" b="1">
+              <a:defRPr sz="3200" b="1">
+                <a:solidFill>
+                  <a:srgbClr val="FFFFFF"/>
+                </a:solidFill>
+              </a:defRPr>
+            </a:pPr>
+            <a:r>
+              <a:t>El Filibusterismo: The Subversive</a:t>
+            </a:r>
+          </a:p>
+          <a:p>
+            <a:pPr>
+              <a:defRPr sz="1600">
                 <a:solidFill>
                   <a:srgbClr val="F2B705"/>
                 </a:solidFill>
               </a:defRPr>
             </a:pPr>
             <a:r>
-              <a:t>COMPARATIVE ANALYSIS</a:t>
-            </a:r>
-          </a:p>
-        </p:txBody>
-      </p:sp>
-      <p:sp>
-        <p:nvSpPr>
-          <p:cNvPr id="4" name="TextBox 3"/>
-          <p:cNvSpPr txBox="1"/>
+              <a:t>Ghent (1891): Simoun and the Approaching Revolutionary Tempest</a:t>
+            </a:r>
+          </a:p>
+        </p:txBody>
+      </p:sp>
+    </p:spTree>
+  </p:cSld>
+  <p:clrMapOvr>
+    <a:masterClrMapping/>
+  </p:clrMapOvr>
+  <mc:AlternateContent xmlns:mc="http://schemas.openxmlformats.org/markup-compatibility/2006">
+    <mc:Choice xmlns:p159="http://schemas.microsoft.com/office/powerpoint/2015/09/main" Requires="p159">
+      <p:transition spd="slow" p14:dur="1500">
+        <p159:morph option="byObject"/>
+      </p:transition>
+    </mc:Choice>
+    <mc:Fallback>
+      <p:transition spd="slow">
+        <p:fade/>
+      </p:transition>
+    </mc:Fallback>
+  </mc:AlternateContent>
+</p:sld>
+</file>
+
+<file path=ppt/slides/slide8.xml><?xml version="1.0" encoding="utf-8"?>
+<p:sld xmlns:p14="http://schemas.microsoft.com/office/powerpoint/2010/main" xmlns:a="http://schemas.openxmlformats.org/drawingml/2006/main" xmlns:p="http://schemas.openxmlformats.org/presentationml/2006/main" xmlns:r="http://schemas.openxmlformats.org/officeDocument/2006/relationships">
+  <p:cSld>
+    <p:spTree>
+      <p:nvGrpSpPr>
+        <p:cNvPr id="1" name=""/>
+        <p:cNvGrpSpPr/>
+        <p:nvPr/>
+      </p:nvGrpSpPr>
+      <p:grpSpPr/>
+      <p:sp>
+        <p:nvSpPr>
+          <p:cNvPr id="2" name="Rectangle 1"/>
+          <p:cNvSpPr/>
           <p:nvPr/>
         </p:nvSpPr>
         <p:spPr>
           <a:xfrm>
-            <a:off x="731520" y="685800"/>
-            <a:ext cx="10515600" cy="731520"/>
+            <a:off x="0" y="0"/>
+            <a:ext cx="12191695" cy="6858000"/>
           </a:xfrm>
           <a:prstGeom prst="rect">
             <a:avLst/>
           </a:prstGeom>
-          <a:noFill/>
-        </p:spPr>
-        <p:txBody>
-          <a:bodyPr wrap="none">
-            <a:spAutoFit/>
-          </a:bodyPr>
-          <a:lstStyle/>
-          <a:p>
-            <a:pPr>
-              <a:defRPr sz="2600" b="1">
-                <a:solidFill>
-                  <a:srgbClr val="FFFFFF"/>
-                </a:solidFill>
-              </a:defRPr>
-            </a:pPr>
-            <a:r>
-              <a:t>Literary Synthesis: Noli vs. Fili</a:t>
-            </a:r>
-          </a:p>
-        </p:txBody>
-      </p:sp>
-      <p:sp>
-        <p:nvSpPr>
-          <p:cNvPr id="5" name="TextBox 4"/>
-          <p:cNvSpPr txBox="1"/>
-          <p:nvPr/>
-        </p:nvSpPr>
-        <p:spPr>
-          <a:xfrm>
-            <a:off x="731520" y="6400800"/>
-            <a:ext cx="10728655" cy="320040"/>
-          </a:xfrm>
-          <a:prstGeom prst="rect">
-            <a:avLst/>
-          </a:prstGeom>
-          <a:noFill/>
-        </p:spPr>
-        <p:txBody>
-          <a:bodyPr wrap="none">
-            <a:spAutoFit/>
-          </a:bodyPr>
-          <a:lstStyle/>
-          <a:p>
-            <a:pPr>
-              <a:defRPr sz="900">
-                <a:solidFill>
-                  <a:srgbClr val="93C5FD"/>
-                </a:solidFill>
-              </a:defRPr>
-            </a:pPr>
-            <a:r>
-              <a:t>STI West Negros University  •  Jhon Paulo V. Gascon  •  Slide 7 of 11</a:t>
-            </a:r>
-          </a:p>
-        </p:txBody>
-      </p:sp>
-      <p:sp>
-        <p:nvSpPr>
-          <p:cNvPr id="6" name="Rounded Rectangle 5"/>
-          <p:cNvSpPr/>
-          <p:nvPr/>
-        </p:nvSpPr>
-        <p:spPr>
-          <a:xfrm>
-            <a:off x="731520" y="1828800"/>
-            <a:ext cx="5212080" cy="4114800"/>
-          </a:xfrm>
-          <a:prstGeom prst="roundRect">
-            <a:avLst/>
-          </a:prstGeom>
           <a:solidFill>
-            <a:srgbClr val="183B64"/>
+            <a:srgbClr val="0F2A4A"/>
           </a:solidFill>
-          <a:ln w="25400">
-            <a:solidFill>
-              <a:srgbClr val="F2B705"/>
-            </a:solidFill>
+          <a:ln>
+            <a:noFill/>
           </a:ln>
         </p:spPr>
         <p:style>
@@ -7352,14 +6497,14 @@
       </p:sp>
       <p:sp>
         <p:nvSpPr>
-          <p:cNvPr id="7" name="TextBox 6"/>
+          <p:cNvPr id="3" name="TextBox 2"/>
           <p:cNvSpPr txBox="1"/>
           <p:nvPr/>
         </p:nvSpPr>
         <p:spPr>
           <a:xfrm>
-            <a:off x="914400" y="2011680"/>
-            <a:ext cx="4846320" cy="3657600"/>
+            <a:off x="731520" y="457200"/>
+            <a:ext cx="10698480" cy="1005840"/>
           </a:xfrm>
           <a:prstGeom prst="rect">
             <a:avLst/>
@@ -7373,98 +6518,74 @@
           <a:lstStyle/>
           <a:p>
             <a:pPr>
-              <a:defRPr sz="1800" b="1">
+              <a:defRPr sz="1100" b="1">
                 <a:solidFill>
                   <a:srgbClr val="F2B705"/>
                 </a:solidFill>
               </a:defRPr>
             </a:pPr>
             <a:r>
-              <a:t>Noli Me Tangere (1887)</a:t>
+              <a:t>CIVIC LEADERSHIP</a:t>
             </a:r>
           </a:p>
           <a:p>
             <a:pPr>
-              <a:spcBef>
-                <a:spcPts val="800"/>
-              </a:spcBef>
-              <a:defRPr sz="1300">
+              <a:defRPr sz="2400" b="1">
                 <a:solidFill>
                   <a:srgbClr val="FFFFFF"/>
                 </a:solidFill>
               </a:defRPr>
             </a:pPr>
             <a:r>
-              <a:t>•  Romantic, idealistic, satirical tone</a:t>
-            </a:r>
-          </a:p>
-          <a:p>
-            <a:pPr>
-              <a:spcBef>
-                <a:spcPts val="800"/>
-              </a:spcBef>
-              <a:defRPr sz="1300">
-                <a:solidFill>
-                  <a:srgbClr val="FFFFFF"/>
-                </a:solidFill>
-              </a:defRPr>
-            </a:pPr>
-            <a:r>
-              <a:t>•  Diagnoses the social cancer of colonial rule</a:t>
-            </a:r>
-          </a:p>
-          <a:p>
-            <a:pPr>
-              <a:spcBef>
-                <a:spcPts val="800"/>
-              </a:spcBef>
-              <a:defRPr sz="1300">
-                <a:solidFill>
-                  <a:srgbClr val="FFFFFF"/>
-                </a:solidFill>
-              </a:defRPr>
-            </a:pPr>
-            <a:r>
-              <a:t>•  Advocates institutional reform through education</a:t>
-            </a:r>
-          </a:p>
-          <a:p>
-            <a:pPr>
-              <a:spcBef>
-                <a:spcPts val="800"/>
-              </a:spcBef>
-              <a:defRPr sz="1300">
-                <a:solidFill>
-                  <a:srgbClr val="FFFFFF"/>
-                </a:solidFill>
-              </a:defRPr>
-            </a:pPr>
-            <a:r>
-              <a:t>•  Crisostomo Ibarra represents youthful hope</a:t>
-            </a:r>
-          </a:p>
-        </p:txBody>
-      </p:sp>
-      <p:sp>
-        <p:nvSpPr>
-          <p:cNvPr id="8" name="Rounded Rectangle 7"/>
+              <a:t>Exile, Science, &amp; Community in Dapitan</a:t>
+            </a:r>
+          </a:p>
+        </p:txBody>
+      </p:sp>
+      <p:pic>
+        <p:nvPicPr>
+          <p:cNvPr id="4" name="!!Content_Image" descr="rizal_dapitan.png"/>
+          <p:cNvPicPr>
+            <a:picLocks noChangeAspect="1"/>
+          </p:cNvPicPr>
+          <p:nvPr/>
+        </p:nvPicPr>
+        <p:blipFill>
+          <a:blip r:embed="rId2"/>
+          <a:stretch>
+            <a:fillRect/>
+          </a:stretch>
+        </p:blipFill>
+        <p:spPr>
+          <a:xfrm>
+            <a:off x="731520" y="1645920"/>
+            <a:ext cx="5029200" cy="4389120"/>
+          </a:xfrm>
+          <a:prstGeom prst="rect">
+            <a:avLst/>
+          </a:prstGeom>
+        </p:spPr>
+      </p:pic>
+      <p:sp>
+        <p:nvSpPr>
+          <p:cNvPr id="5" name="!!Card_1"/>
           <p:cNvSpPr/>
           <p:nvPr/>
         </p:nvSpPr>
         <p:spPr>
           <a:xfrm>
-            <a:off x="6217920" y="1828800"/>
-            <a:ext cx="5212080" cy="4114800"/>
+            <a:off x="6126480" y="1645920"/>
+            <a:ext cx="5303520" cy="1280160"/>
           </a:xfrm>
           <a:prstGeom prst="roundRect">
             <a:avLst/>
           </a:prstGeom>
           <a:solidFill>
-            <a:srgbClr val="183B64"/>
+            <a:srgbClr val="193A62"/>
           </a:solidFill>
-          <a:ln w="25400">
+          <a:ln w="12700">
             <a:solidFill>
-              <a:srgbClr val="3E7CB1"/>
+              <a:srgbClr val="F2B705"/>
             </a:solidFill>
           </a:ln>
         </p:spPr>
@@ -7483,104 +6604,162 @@
           </a:fontRef>
         </p:style>
         <p:txBody>
-          <a:bodyPr rtlCol="0" anchor="ctr"/>
-          <a:lstStyle/>
-          <a:p>
-            <a:pPr algn="ctr"/>
-          </a:p>
-        </p:txBody>
-      </p:sp>
-      <p:sp>
-        <p:nvSpPr>
-          <p:cNvPr id="9" name="TextBox 8"/>
-          <p:cNvSpPr txBox="1"/>
+          <a:bodyPr rtlCol="0" anchor="ctr" wrap="square"/>
+          <a:lstStyle/>
+          <a:p>
+            <a:pPr algn="ctr">
+              <a:defRPr b="1" sz="1300">
+                <a:solidFill>
+                  <a:srgbClr val="FFFFFF"/>
+                </a:solidFill>
+              </a:defRPr>
+            </a:pPr>
+            <a:r>
+              <a:t>Civic Engineer &amp; Educator</a:t>
+            </a:r>
+          </a:p>
+          <a:p>
+            <a:pPr>
+              <a:defRPr sz="1050">
+                <a:solidFill>
+                  <a:srgbClr val="F0F5FF"/>
+                </a:solidFill>
+              </a:defRPr>
+            </a:pPr>
+            <a:r>
+              <a:t>Constructed a town waterworks system, established a school for local youth, and introduced modern agriculture.</a:t>
+            </a:r>
+          </a:p>
+        </p:txBody>
+      </p:sp>
+      <p:sp>
+        <p:nvSpPr>
+          <p:cNvPr id="6" name="!!Card_2"/>
+          <p:cNvSpPr/>
           <p:nvPr/>
         </p:nvSpPr>
         <p:spPr>
           <a:xfrm>
-            <a:off x="6400800" y="2011680"/>
-            <a:ext cx="4846320" cy="3657600"/>
-          </a:xfrm>
-          <a:prstGeom prst="rect">
+            <a:off x="6126480" y="3108960"/>
+            <a:ext cx="5303520" cy="1280160"/>
+          </a:xfrm>
+          <a:prstGeom prst="roundRect">
             <a:avLst/>
           </a:prstGeom>
-          <a:noFill/>
-        </p:spPr>
-        <p:txBody>
-          <a:bodyPr wrap="square">
-            <a:spAutoFit/>
-          </a:bodyPr>
-          <a:lstStyle/>
+          <a:solidFill>
+            <a:srgbClr val="193A62"/>
+          </a:solidFill>
+          <a:ln w="12700">
+            <a:solidFill>
+              <a:srgbClr val="F2B705"/>
+            </a:solidFill>
+          </a:ln>
+        </p:spPr>
+        <p:style>
+          <a:lnRef idx="1">
+            <a:schemeClr val="accent1"/>
+          </a:lnRef>
+          <a:fillRef idx="3">
+            <a:schemeClr val="accent1"/>
+          </a:fillRef>
+          <a:effectRef idx="2">
+            <a:schemeClr val="accent1"/>
+          </a:effectRef>
+          <a:fontRef idx="minor">
+            <a:schemeClr val="lt1"/>
+          </a:fontRef>
+        </p:style>
+        <p:txBody>
+          <a:bodyPr rtlCol="0" anchor="ctr" wrap="square"/>
+          <a:lstStyle/>
+          <a:p>
+            <a:pPr algn="ctr">
+              <a:defRPr b="1" sz="1300">
+                <a:solidFill>
+                  <a:srgbClr val="FFFFFF"/>
+                </a:solidFill>
+              </a:defRPr>
+            </a:pPr>
+            <a:r>
+              <a:t>Biological Discoveries</a:t>
+            </a:r>
+          </a:p>
           <a:p>
             <a:pPr>
-              <a:defRPr sz="1800" b="1">
-                <a:solidFill>
-                  <a:srgbClr val="3E7CB1"/>
+              <a:defRPr sz="1050">
+                <a:solidFill>
+                  <a:srgbClr val="F0F5FF"/>
                 </a:solidFill>
               </a:defRPr>
             </a:pPr>
             <a:r>
-              <a:t>El Filibusterismo (1891)</a:t>
+              <a:t>Collected rare specimens, discovering Draco rizali (flying lizard) and Apogonia rizali (beetle).</a:t>
+            </a:r>
+          </a:p>
+        </p:txBody>
+      </p:sp>
+      <p:sp>
+        <p:nvSpPr>
+          <p:cNvPr id="7" name="!!Card_3"/>
+          <p:cNvSpPr/>
+          <p:nvPr/>
+        </p:nvSpPr>
+        <p:spPr>
+          <a:xfrm>
+            <a:off x="6126480" y="4572000"/>
+            <a:ext cx="5303520" cy="1280160"/>
+          </a:xfrm>
+          <a:prstGeom prst="roundRect">
+            <a:avLst/>
+          </a:prstGeom>
+          <a:solidFill>
+            <a:srgbClr val="193A62"/>
+          </a:solidFill>
+          <a:ln w="12700">
+            <a:solidFill>
+              <a:srgbClr val="F2B705"/>
+            </a:solidFill>
+          </a:ln>
+        </p:spPr>
+        <p:style>
+          <a:lnRef idx="1">
+            <a:schemeClr val="accent1"/>
+          </a:lnRef>
+          <a:fillRef idx="3">
+            <a:schemeClr val="accent1"/>
+          </a:fillRef>
+          <a:effectRef idx="2">
+            <a:schemeClr val="accent1"/>
+          </a:effectRef>
+          <a:fontRef idx="minor">
+            <a:schemeClr val="lt1"/>
+          </a:fontRef>
+        </p:style>
+        <p:txBody>
+          <a:bodyPr rtlCol="0" anchor="ctr" wrap="square"/>
+          <a:lstStyle/>
+          <a:p>
+            <a:pPr algn="ctr">
+              <a:defRPr b="1" sz="1300">
+                <a:solidFill>
+                  <a:srgbClr val="FFFFFF"/>
+                </a:solidFill>
+              </a:defRPr>
+            </a:pPr>
+            <a:r>
+              <a:t>Model Community Development</a:t>
             </a:r>
           </a:p>
           <a:p>
             <a:pPr>
-              <a:spcBef>
-                <a:spcPts val="800"/>
-              </a:spcBef>
-              <a:defRPr sz="1300">
-                <a:solidFill>
-                  <a:srgbClr val="FFFFFF"/>
+              <a:defRPr sz="1050">
+                <a:solidFill>
+                  <a:srgbClr val="F0F5FF"/>
                 </a:solidFill>
               </a:defRPr>
             </a:pPr>
             <a:r>
-              <a:t>•  Dark, tragic, revolutionary urgency</a:t>
-            </a:r>
-          </a:p>
-          <a:p>
-            <a:pPr>
-              <a:spcBef>
-                <a:spcPts val="800"/>
-              </a:spcBef>
-              <a:defRPr sz="1300">
-                <a:solidFill>
-                  <a:srgbClr val="FFFFFF"/>
-                </a:solidFill>
-              </a:defRPr>
-            </a:pPr>
-            <a:r>
-              <a:t>•  Exposes the futility of corrupt political compromises</a:t>
-            </a:r>
-          </a:p>
-          <a:p>
-            <a:pPr>
-              <a:spcBef>
-                <a:spcPts val="800"/>
-              </a:spcBef>
-              <a:defRPr sz="1300">
-                <a:solidFill>
-                  <a:srgbClr val="FFFFFF"/>
-                </a:solidFill>
-              </a:defRPr>
-            </a:pPr>
-            <a:r>
-              <a:t>•  Simoun plots violent retribution</a:t>
-            </a:r>
-          </a:p>
-          <a:p>
-            <a:pPr>
-              <a:spcBef>
-                <a:spcPts val="800"/>
-              </a:spcBef>
-              <a:defRPr sz="1300">
-                <a:solidFill>
-                  <a:srgbClr val="FFFFFF"/>
-                </a:solidFill>
-              </a:defRPr>
-            </a:pPr>
-            <a:r>
-              <a:t>•  Warns that freedom without virtue leads to tyranny</a:t>
+              <a:t>Demonstrated that true nation-building starts with grassroots public health, education, and economic cooperatives.</a:t>
             </a:r>
           </a:p>
         </p:txBody>
@@ -7596,8 +6775,8 @@
 </p:sld>
 </file>
 
-<file path=ppt/slides/slide8.xml><?xml version="1.0" encoding="utf-8"?>
-<p:sld xmlns:a="http://schemas.openxmlformats.org/drawingml/2006/main" xmlns:p="http://schemas.openxmlformats.org/presentationml/2006/main" xmlns:r="http://schemas.openxmlformats.org/officeDocument/2006/relationships">
+<file path=ppt/slides/slide9.xml><?xml version="1.0" encoding="utf-8"?>
+<p:sld xmlns:p14="http://schemas.microsoft.com/office/powerpoint/2010/main" xmlns:a="http://schemas.openxmlformats.org/drawingml/2006/main" xmlns:p="http://schemas.openxmlformats.org/presentationml/2006/main" xmlns:r="http://schemas.openxmlformats.org/officeDocument/2006/relationships">
   <p:cSld>
     <p:spTree>
       <p:nvGrpSpPr>
@@ -7657,8 +6836,8 @@
         </p:nvSpPr>
         <p:spPr>
           <a:xfrm>
-            <a:off x="731520" y="6400800"/>
-            <a:ext cx="10728655" cy="320040"/>
+            <a:off x="731520" y="457200"/>
+            <a:ext cx="10698480" cy="1005840"/>
           </a:xfrm>
           <a:prstGeom prst="rect">
             <a:avLst/>
@@ -7666,322 +6845,52 @@
           <a:noFill/>
         </p:spPr>
         <p:txBody>
-          <a:bodyPr wrap="none">
+          <a:bodyPr wrap="square">
             <a:spAutoFit/>
           </a:bodyPr>
           <a:lstStyle/>
           <a:p>
             <a:pPr>
-              <a:defRPr sz="900">
-                <a:solidFill>
-                  <a:srgbClr val="93C5FD"/>
+              <a:defRPr sz="1100" b="1">
+                <a:solidFill>
+                  <a:srgbClr val="F2B705"/>
                 </a:solidFill>
               </a:defRPr>
             </a:pPr>
             <a:r>
-              <a:t>STI West Negros University  •  Jhon Paulo V. Gascon  •  Slide 8 of 11</a:t>
-            </a:r>
-          </a:p>
-        </p:txBody>
-      </p:sp>
-      <p:sp>
-        <p:nvSpPr>
-          <p:cNvPr id="4" name="Rectangle 3"/>
+              <a:t>MODERN RELEVANCE</a:t>
+            </a:r>
+          </a:p>
+          <a:p>
+            <a:pPr>
+              <a:defRPr sz="2400" b="1">
+                <a:solidFill>
+                  <a:srgbClr val="FFFFFF"/>
+                </a:solidFill>
+              </a:defRPr>
+            </a:pPr>
+            <a:r>
+              <a:t>Core Lessons from Rizal for BSIT Students</a:t>
+            </a:r>
+          </a:p>
+        </p:txBody>
+      </p:sp>
+      <p:sp>
+        <p:nvSpPr>
+          <p:cNvPr id="4" name="!!Card_1"/>
           <p:cNvSpPr/>
           <p:nvPr/>
         </p:nvSpPr>
         <p:spPr>
           <a:xfrm>
-            <a:off x="731520" y="2286000"/>
-            <a:ext cx="457200" cy="2560320"/>
-          </a:xfrm>
-          <a:prstGeom prst="rect">
-            <a:avLst/>
-          </a:prstGeom>
-          <a:solidFill>
-            <a:srgbClr val="F2B705"/>
-          </a:solidFill>
-          <a:ln>
-            <a:noFill/>
-          </a:ln>
-        </p:spPr>
-        <p:style>
-          <a:lnRef idx="1">
-            <a:schemeClr val="accent1"/>
-          </a:lnRef>
-          <a:fillRef idx="3">
-            <a:schemeClr val="accent1"/>
-          </a:fillRef>
-          <a:effectRef idx="2">
-            <a:schemeClr val="accent1"/>
-          </a:effectRef>
-          <a:fontRef idx="minor">
-            <a:schemeClr val="lt1"/>
-          </a:fontRef>
-        </p:style>
-        <p:txBody>
-          <a:bodyPr rtlCol="0" anchor="ctr"/>
-          <a:lstStyle/>
-          <a:p>
-            <a:pPr algn="ctr"/>
-          </a:p>
-        </p:txBody>
-      </p:sp>
-      <p:sp>
-        <p:nvSpPr>
-          <p:cNvPr id="5" name="TextBox 4"/>
-          <p:cNvSpPr txBox="1"/>
-          <p:nvPr/>
-        </p:nvSpPr>
-        <p:spPr>
-          <a:xfrm>
-            <a:off x="1463040" y="2194560"/>
-            <a:ext cx="9601200" cy="1371600"/>
-          </a:xfrm>
-          <a:prstGeom prst="rect">
-            <a:avLst/>
-          </a:prstGeom>
-          <a:noFill/>
-        </p:spPr>
-        <p:txBody>
-          <a:bodyPr wrap="none">
-            <a:spAutoFit/>
-          </a:bodyPr>
-          <a:lstStyle/>
-          <a:p>
-            <a:pPr>
-              <a:defRPr sz="3800" b="1">
-                <a:solidFill>
-                  <a:srgbClr val="FFFFFF"/>
-                </a:solidFill>
-              </a:defRPr>
-            </a:pPr>
-            <a:r>
-              <a:t>Part II: Civic Action in Dapitan &amp; Final Sacrifice</a:t>
-            </a:r>
-          </a:p>
-        </p:txBody>
-      </p:sp>
-      <p:sp>
-        <p:nvSpPr>
-          <p:cNvPr id="6" name="TextBox 5"/>
-          <p:cNvSpPr txBox="1"/>
-          <p:nvPr/>
-        </p:nvSpPr>
-        <p:spPr>
-          <a:xfrm>
-            <a:off x="1463040" y="3657600"/>
-            <a:ext cx="9601200" cy="1371600"/>
-          </a:xfrm>
-          <a:prstGeom prst="rect">
-            <a:avLst/>
-          </a:prstGeom>
-          <a:noFill/>
-        </p:spPr>
-        <p:txBody>
-          <a:bodyPr wrap="none">
-            <a:spAutoFit/>
-          </a:bodyPr>
-          <a:lstStyle/>
-          <a:p>
-            <a:pPr>
-              <a:defRPr sz="2200">
-                <a:solidFill>
-                  <a:srgbClr val="93C5FD"/>
-                </a:solidFill>
-              </a:defRPr>
-            </a:pPr>
-            <a:r>
-              <a:t>Translating philosophical ideals into practical community progress.</a:t>
-            </a:r>
-          </a:p>
-        </p:txBody>
-      </p:sp>
-    </p:spTree>
-  </p:cSld>
-  <p:clrMapOvr>
-    <a:masterClrMapping/>
-  </p:clrMapOvr>
-  <p:transition spd="med">
-    <p:push dir="u"/>
-  </p:transition>
-</p:sld>
-</file>
-
-<file path=ppt/slides/slide9.xml><?xml version="1.0" encoding="utf-8"?>
-<p:sld xmlns:a="http://schemas.openxmlformats.org/drawingml/2006/main" xmlns:p="http://schemas.openxmlformats.org/presentationml/2006/main" xmlns:r="http://schemas.openxmlformats.org/officeDocument/2006/relationships">
-  <p:cSld>
-    <p:spTree>
-      <p:nvGrpSpPr>
-        <p:cNvPr id="1" name=""/>
-        <p:cNvGrpSpPr/>
-        <p:nvPr/>
-      </p:nvGrpSpPr>
-      <p:grpSpPr/>
-      <p:sp>
-        <p:nvSpPr>
-          <p:cNvPr id="2" name="Rectangle 1"/>
-          <p:cNvSpPr/>
-          <p:nvPr/>
-        </p:nvSpPr>
-        <p:spPr>
-          <a:xfrm>
-            <a:off x="0" y="0"/>
-            <a:ext cx="12191695" cy="6858000"/>
-          </a:xfrm>
-          <a:prstGeom prst="rect">
-            <a:avLst/>
-          </a:prstGeom>
-          <a:solidFill>
-            <a:srgbClr val="0F2A4A"/>
-          </a:solidFill>
-          <a:ln>
-            <a:noFill/>
-          </a:ln>
-        </p:spPr>
-        <p:style>
-          <a:lnRef idx="1">
-            <a:schemeClr val="accent1"/>
-          </a:lnRef>
-          <a:fillRef idx="3">
-            <a:schemeClr val="accent1"/>
-          </a:fillRef>
-          <a:effectRef idx="2">
-            <a:schemeClr val="accent1"/>
-          </a:effectRef>
-          <a:fontRef idx="minor">
-            <a:schemeClr val="lt1"/>
-          </a:fontRef>
-        </p:style>
-        <p:txBody>
-          <a:bodyPr rtlCol="0" anchor="ctr"/>
-          <a:lstStyle/>
-          <a:p>
-            <a:pPr algn="ctr"/>
-          </a:p>
-        </p:txBody>
-      </p:sp>
-      <p:sp>
-        <p:nvSpPr>
-          <p:cNvPr id="3" name="TextBox 2"/>
-          <p:cNvSpPr txBox="1"/>
-          <p:nvPr/>
-        </p:nvSpPr>
-        <p:spPr>
-          <a:xfrm>
-            <a:off x="731520" y="365760"/>
-            <a:ext cx="10058400" cy="365760"/>
-          </a:xfrm>
-          <a:prstGeom prst="rect">
-            <a:avLst/>
-          </a:prstGeom>
-          <a:noFill/>
-        </p:spPr>
-        <p:txBody>
-          <a:bodyPr wrap="none">
-            <a:spAutoFit/>
-          </a:bodyPr>
-          <a:lstStyle/>
-          <a:p>
-            <a:pPr>
-              <a:defRPr sz="1100" b="1">
-                <a:solidFill>
-                  <a:srgbClr val="F2B705"/>
-                </a:solidFill>
-              </a:defRPr>
-            </a:pPr>
-            <a:r>
-              <a:t>EXECUTION METHODOLOGY</a:t>
-            </a:r>
-          </a:p>
-        </p:txBody>
-      </p:sp>
-      <p:sp>
-        <p:nvSpPr>
-          <p:cNvPr id="4" name="TextBox 3"/>
-          <p:cNvSpPr txBox="1"/>
-          <p:nvPr/>
-        </p:nvSpPr>
-        <p:spPr>
-          <a:xfrm>
-            <a:off x="731520" y="685800"/>
-            <a:ext cx="10515600" cy="731520"/>
-          </a:xfrm>
-          <a:prstGeom prst="rect">
-            <a:avLst/>
-          </a:prstGeom>
-          <a:noFill/>
-        </p:spPr>
-        <p:txBody>
-          <a:bodyPr wrap="none">
-            <a:spAutoFit/>
-          </a:bodyPr>
-          <a:lstStyle/>
-          <a:p>
-            <a:pPr>
-              <a:defRPr sz="2600" b="1">
-                <a:solidFill>
-                  <a:srgbClr val="FFFFFF"/>
-                </a:solidFill>
-              </a:defRPr>
-            </a:pPr>
-            <a:r>
-              <a:t>Rizal's Practical Community Development Model</a:t>
-            </a:r>
-          </a:p>
-        </p:txBody>
-      </p:sp>
-      <p:sp>
-        <p:nvSpPr>
-          <p:cNvPr id="5" name="TextBox 4"/>
-          <p:cNvSpPr txBox="1"/>
-          <p:nvPr/>
-        </p:nvSpPr>
-        <p:spPr>
-          <a:xfrm>
-            <a:off x="731520" y="6400800"/>
-            <a:ext cx="10728655" cy="320040"/>
-          </a:xfrm>
-          <a:prstGeom prst="rect">
-            <a:avLst/>
-          </a:prstGeom>
-          <a:noFill/>
-        </p:spPr>
-        <p:txBody>
-          <a:bodyPr wrap="none">
-            <a:spAutoFit/>
-          </a:bodyPr>
-          <a:lstStyle/>
-          <a:p>
-            <a:pPr>
-              <a:defRPr sz="900">
-                <a:solidFill>
-                  <a:srgbClr val="93C5FD"/>
-                </a:solidFill>
-              </a:defRPr>
-            </a:pPr>
-            <a:r>
-              <a:t>STI West Negros University  •  Jhon Paulo V. Gascon  •  Slide 9 of 11</a:t>
-            </a:r>
-          </a:p>
-        </p:txBody>
-      </p:sp>
-      <p:sp>
-        <p:nvSpPr>
-          <p:cNvPr id="6" name="Rounded Rectangle 5"/>
-          <p:cNvSpPr/>
-          <p:nvPr/>
-        </p:nvSpPr>
-        <p:spPr>
-          <a:xfrm>
-            <a:off x="731520" y="2011680"/>
-            <a:ext cx="2514600" cy="3840480"/>
+            <a:off x="731520" y="1645920"/>
+            <a:ext cx="3291840" cy="4114800"/>
           </a:xfrm>
           <a:prstGeom prst="roundRect">
             <a:avLst/>
           </a:prstGeom>
           <a:solidFill>
-            <a:srgbClr val="183B64"/>
+            <a:srgbClr val="193A62"/>
           </a:solidFill>
           <a:ln w="19050">
             <a:solidFill>
@@ -8004,94 +6913,50 @@
           </a:fontRef>
         </p:style>
         <p:txBody>
-          <a:bodyPr rtlCol="0" anchor="ctr"/>
-          <a:lstStyle/>
-          <a:p>
-            <a:pPr algn="ctr"/>
-          </a:p>
-        </p:txBody>
-      </p:sp>
-      <p:sp>
-        <p:nvSpPr>
-          <p:cNvPr id="7" name="TextBox 6"/>
-          <p:cNvSpPr txBox="1"/>
-          <p:nvPr/>
-        </p:nvSpPr>
-        <p:spPr>
-          <a:xfrm>
-            <a:off x="868680" y="2194560"/>
-            <a:ext cx="2240280" cy="3474720"/>
-          </a:xfrm>
-          <a:prstGeom prst="rect">
-            <a:avLst/>
-          </a:prstGeom>
-          <a:noFill/>
-        </p:spPr>
-        <p:txBody>
-          <a:bodyPr wrap="square">
-            <a:spAutoFit/>
-          </a:bodyPr>
-          <a:lstStyle/>
+          <a:bodyPr rtlCol="0" anchor="ctr" wrap="square"/>
+          <a:lstStyle/>
+          <a:p>
+            <a:pPr algn="ctr">
+              <a:defRPr b="1" sz="1500">
+                <a:solidFill>
+                  <a:srgbClr val="F2B705"/>
+                </a:solidFill>
+              </a:defRPr>
+            </a:pPr>
+            <a:r>
+              <a:t>1. Excellence in Craft</a:t>
+            </a:r>
+          </a:p>
           <a:p>
             <a:pPr>
-              <a:defRPr sz="1300" b="1">
-                <a:solidFill>
-                  <a:srgbClr val="3E7CB1"/>
+              <a:defRPr sz="1100">
+                <a:solidFill>
+                  <a:srgbClr val="F0F0F0"/>
                 </a:solidFill>
               </a:defRPr>
             </a:pPr>
             <a:r>
-              <a:t>Step 1</a:t>
-            </a:r>
-          </a:p>
-          <a:p>
-            <a:pPr>
-              <a:spcBef>
-                <a:spcPts val="600"/>
-              </a:spcBef>
-              <a:defRPr sz="1600" b="1">
-                <a:solidFill>
-                  <a:srgbClr val="FFFFFF"/>
-                </a:solidFill>
-              </a:defRPr>
-            </a:pPr>
-            <a:r>
-              <a:t>Healthcare Access</a:t>
-            </a:r>
-          </a:p>
-          <a:p>
-            <a:pPr>
-              <a:spcBef>
-                <a:spcPts val="800"/>
-              </a:spcBef>
-              <a:defRPr sz="1200">
-                <a:solidFill>
-                  <a:srgbClr val="93C5FD"/>
-                </a:solidFill>
-              </a:defRPr>
-            </a:pPr>
-            <a:r>
-              <a:t>Providing free clinical consultations and cataract surgeries to rural peasants.</a:t>
-            </a:r>
-          </a:p>
-        </p:txBody>
-      </p:sp>
-      <p:sp>
-        <p:nvSpPr>
-          <p:cNvPr id="8" name="Rounded Rectangle 7"/>
+              <a:t>Rizal dedicated himself to world-class mastery in medicine, writing, and linguistics. We must bring equal dedication to technology.</a:t>
+            </a:r>
+          </a:p>
+        </p:txBody>
+      </p:sp>
+      <p:sp>
+        <p:nvSpPr>
+          <p:cNvPr id="5" name="!!Card_2"/>
           <p:cNvSpPr/>
           <p:nvPr/>
         </p:nvSpPr>
         <p:spPr>
           <a:xfrm>
-            <a:off x="3429000" y="2011680"/>
-            <a:ext cx="2514600" cy="3840480"/>
+            <a:off x="4389120" y="1645920"/>
+            <a:ext cx="3291840" cy="4114800"/>
           </a:xfrm>
           <a:prstGeom prst="roundRect">
             <a:avLst/>
           </a:prstGeom>
           <a:solidFill>
-            <a:srgbClr val="183B64"/>
+            <a:srgbClr val="193A62"/>
           </a:solidFill>
           <a:ln w="19050">
             <a:solidFill>
@@ -8114,94 +6979,50 @@
           </a:fontRef>
         </p:style>
         <p:txBody>
-          <a:bodyPr rtlCol="0" anchor="ctr"/>
-          <a:lstStyle/>
-          <a:p>
-            <a:pPr algn="ctr"/>
-          </a:p>
-        </p:txBody>
-      </p:sp>
-      <p:sp>
-        <p:nvSpPr>
-          <p:cNvPr id="9" name="TextBox 8"/>
-          <p:cNvSpPr txBox="1"/>
-          <p:nvPr/>
-        </p:nvSpPr>
-        <p:spPr>
-          <a:xfrm>
-            <a:off x="3566160" y="2194560"/>
-            <a:ext cx="2240280" cy="3474720"/>
-          </a:xfrm>
-          <a:prstGeom prst="rect">
-            <a:avLst/>
-          </a:prstGeom>
-          <a:noFill/>
-        </p:spPr>
-        <p:txBody>
-          <a:bodyPr wrap="square">
-            <a:spAutoFit/>
-          </a:bodyPr>
-          <a:lstStyle/>
+          <a:bodyPr rtlCol="0" anchor="ctr" wrap="square"/>
+          <a:lstStyle/>
+          <a:p>
+            <a:pPr algn="ctr">
+              <a:defRPr b="1" sz="1500">
+                <a:solidFill>
+                  <a:srgbClr val="F2B705"/>
+                </a:solidFill>
+              </a:defRPr>
+            </a:pPr>
+            <a:r>
+              <a:t>2. Civic Tech Innovation</a:t>
+            </a:r>
+          </a:p>
           <a:p>
             <a:pPr>
-              <a:defRPr sz="1300" b="1">
-                <a:solidFill>
-                  <a:srgbClr val="3E7CB1"/>
+              <a:defRPr sz="1100">
+                <a:solidFill>
+                  <a:srgbClr val="F0F0F0"/>
                 </a:solidFill>
               </a:defRPr>
             </a:pPr>
             <a:r>
-              <a:t>Step 2</a:t>
-            </a:r>
-          </a:p>
-          <a:p>
-            <a:pPr>
-              <a:spcBef>
-                <a:spcPts val="600"/>
-              </a:spcBef>
-              <a:defRPr sz="1600" b="1">
-                <a:solidFill>
-                  <a:srgbClr val="FFFFFF"/>
-                </a:solidFill>
-              </a:defRPr>
-            </a:pPr>
-            <a:r>
-              <a:t>Public Infrastructure</a:t>
-            </a:r>
-          </a:p>
-          <a:p>
-            <a:pPr>
-              <a:spcBef>
-                <a:spcPts val="800"/>
-              </a:spcBef>
-              <a:defRPr sz="1200">
-                <a:solidFill>
-                  <a:srgbClr val="93C5FD"/>
-                </a:solidFill>
-              </a:defRPr>
-            </a:pPr>
-            <a:r>
-              <a:t>Constructing municipal waterworks, dams, and street lighting systems.</a:t>
-            </a:r>
-          </a:p>
-        </p:txBody>
-      </p:sp>
-      <p:sp>
-        <p:nvSpPr>
-          <p:cNvPr id="10" name="Rounded Rectangle 9"/>
+              <a:t>Using digital tools to solve tangible community problems, echoing Rizal's hydraulic engineering in Dapitan.</a:t>
+            </a:r>
+          </a:p>
+        </p:txBody>
+      </p:sp>
+      <p:sp>
+        <p:nvSpPr>
+          <p:cNvPr id="6" name="!!Card_3"/>
           <p:cNvSpPr/>
           <p:nvPr/>
         </p:nvSpPr>
         <p:spPr>
           <a:xfrm>
-            <a:off x="6126480" y="2011680"/>
-            <a:ext cx="2514600" cy="3840480"/>
+            <a:off x="8046720" y="1645920"/>
+            <a:ext cx="3291840" cy="4114800"/>
           </a:xfrm>
           <a:prstGeom prst="roundRect">
             <a:avLst/>
           </a:prstGeom>
           <a:solidFill>
-            <a:srgbClr val="183B64"/>
+            <a:srgbClr val="193A62"/>
           </a:solidFill>
           <a:ln w="19050">
             <a:solidFill>
@@ -8224,184 +7045,30 @@
           </a:fontRef>
         </p:style>
         <p:txBody>
-          <a:bodyPr rtlCol="0" anchor="ctr"/>
-          <a:lstStyle/>
-          <a:p>
-            <a:pPr algn="ctr"/>
-          </a:p>
-        </p:txBody>
-      </p:sp>
-      <p:sp>
-        <p:nvSpPr>
-          <p:cNvPr id="11" name="TextBox 10"/>
-          <p:cNvSpPr txBox="1"/>
-          <p:nvPr/>
-        </p:nvSpPr>
-        <p:spPr>
-          <a:xfrm>
-            <a:off x="6263640" y="2194560"/>
-            <a:ext cx="2240280" cy="3474720"/>
-          </a:xfrm>
-          <a:prstGeom prst="rect">
-            <a:avLst/>
-          </a:prstGeom>
-          <a:noFill/>
-        </p:spPr>
-        <p:txBody>
-          <a:bodyPr wrap="square">
-            <a:spAutoFit/>
-          </a:bodyPr>
-          <a:lstStyle/>
+          <a:bodyPr rtlCol="0" anchor="ctr" wrap="square"/>
+          <a:lstStyle/>
+          <a:p>
+            <a:pPr algn="ctr">
+              <a:defRPr b="1" sz="1500">
+                <a:solidFill>
+                  <a:srgbClr val="F2B705"/>
+                </a:solidFill>
+              </a:defRPr>
+            </a:pPr>
+            <a:r>
+              <a:t>3. Ethical Responsibility</a:t>
+            </a:r>
+          </a:p>
           <a:p>
             <a:pPr>
-              <a:defRPr sz="1300" b="1">
-                <a:solidFill>
-                  <a:srgbClr val="3E7CB1"/>
+              <a:defRPr sz="1100">
+                <a:solidFill>
+                  <a:srgbClr val="F0F0F0"/>
                 </a:solidFill>
               </a:defRPr>
             </a:pPr>
             <a:r>
-              <a:t>Step 3</a:t>
-            </a:r>
-          </a:p>
-          <a:p>
-            <a:pPr>
-              <a:spcBef>
-                <a:spcPts val="600"/>
-              </a:spcBef>
-              <a:defRPr sz="1600" b="1">
-                <a:solidFill>
-                  <a:srgbClr val="FFFFFF"/>
-                </a:solidFill>
-              </a:defRPr>
-            </a:pPr>
-            <a:r>
-              <a:t>Agricultural Trade</a:t>
-            </a:r>
-          </a:p>
-          <a:p>
-            <a:pPr>
-              <a:spcBef>
-                <a:spcPts val="800"/>
-              </a:spcBef>
-              <a:defRPr sz="1200">
-                <a:solidFill>
-                  <a:srgbClr val="93C5FD"/>
-                </a:solidFill>
-              </a:defRPr>
-            </a:pPr>
-            <a:r>
-              <a:t>Establishing farmer cooperatives to break foreign middleman monopolies.</a:t>
-            </a:r>
-          </a:p>
-        </p:txBody>
-      </p:sp>
-      <p:sp>
-        <p:nvSpPr>
-          <p:cNvPr id="12" name="Rounded Rectangle 11"/>
-          <p:cNvSpPr/>
-          <p:nvPr/>
-        </p:nvSpPr>
-        <p:spPr>
-          <a:xfrm>
-            <a:off x="8823960" y="2011680"/>
-            <a:ext cx="2514600" cy="3840480"/>
-          </a:xfrm>
-          <a:prstGeom prst="roundRect">
-            <a:avLst/>
-          </a:prstGeom>
-          <a:solidFill>
-            <a:srgbClr val="183B64"/>
-          </a:solidFill>
-          <a:ln w="19050">
-            <a:solidFill>
-              <a:srgbClr val="F2B705"/>
-            </a:solidFill>
-          </a:ln>
-        </p:spPr>
-        <p:style>
-          <a:lnRef idx="1">
-            <a:schemeClr val="accent1"/>
-          </a:lnRef>
-          <a:fillRef idx="3">
-            <a:schemeClr val="accent1"/>
-          </a:fillRef>
-          <a:effectRef idx="2">
-            <a:schemeClr val="accent1"/>
-          </a:effectRef>
-          <a:fontRef idx="minor">
-            <a:schemeClr val="lt1"/>
-          </a:fontRef>
-        </p:style>
-        <p:txBody>
-          <a:bodyPr rtlCol="0" anchor="ctr"/>
-          <a:lstStyle/>
-          <a:p>
-            <a:pPr algn="ctr"/>
-          </a:p>
-        </p:txBody>
-      </p:sp>
-      <p:sp>
-        <p:nvSpPr>
-          <p:cNvPr id="13" name="TextBox 12"/>
-          <p:cNvSpPr txBox="1"/>
-          <p:nvPr/>
-        </p:nvSpPr>
-        <p:spPr>
-          <a:xfrm>
-            <a:off x="8961120" y="2194560"/>
-            <a:ext cx="2240280" cy="3474720"/>
-          </a:xfrm>
-          <a:prstGeom prst="rect">
-            <a:avLst/>
-          </a:prstGeom>
-          <a:noFill/>
-        </p:spPr>
-        <p:txBody>
-          <a:bodyPr wrap="square">
-            <a:spAutoFit/>
-          </a:bodyPr>
-          <a:lstStyle/>
-          <a:p>
-            <a:pPr>
-              <a:defRPr sz="1300" b="1">
-                <a:solidFill>
-                  <a:srgbClr val="3E7CB1"/>
-                </a:solidFill>
-              </a:defRPr>
-            </a:pPr>
-            <a:r>
-              <a:t>Step 4</a:t>
-            </a:r>
-          </a:p>
-          <a:p>
-            <a:pPr>
-              <a:spcBef>
-                <a:spcPts val="600"/>
-              </a:spcBef>
-              <a:defRPr sz="1600" b="1">
-                <a:solidFill>
-                  <a:srgbClr val="FFFFFF"/>
-                </a:solidFill>
-              </a:defRPr>
-            </a:pPr>
-            <a:r>
-              <a:t>Youth Schooling</a:t>
-            </a:r>
-          </a:p>
-          <a:p>
-            <a:pPr>
-              <a:spcBef>
-                <a:spcPts val="800"/>
-              </a:spcBef>
-              <a:defRPr sz="1200">
-                <a:solidFill>
-                  <a:srgbClr val="93C5FD"/>
-                </a:solidFill>
-              </a:defRPr>
-            </a:pPr>
-            <a:r>
-              <a:t>Mentoring young boys in English, sciences, swimming, and martial arts.</a:t>
+              <a:t>Recognizing that technological expertise carries a patriotic duty to defend truth, privacy, and social equity.</a:t>
             </a:r>
           </a:p>
         </p:txBody>
@@ -8411,9 +7078,18 @@
   <p:clrMapOvr>
     <a:masterClrMapping/>
   </p:clrMapOvr>
-  <p:transition spd="med">
-    <p:fade/>
-  </p:transition>
+  <mc:AlternateContent xmlns:mc="http://schemas.openxmlformats.org/markup-compatibility/2006">
+    <mc:Choice xmlns:p159="http://schemas.microsoft.com/office/powerpoint/2015/09/main" Requires="p159">
+      <p:transition spd="slow" p14:dur="1500">
+        <p159:morph option="byObject"/>
+      </p:transition>
+    </mc:Choice>
+    <mc:Fallback>
+      <p:transition spd="slow">
+        <p:fade/>
+      </p:transition>
+    </mc:Fallback>
+  </mc:AlternateContent>
 </p:sld>
 </file>
 

</xml_diff>